<commit_message>
Redesign stability slides with editorial typography and editable charts
</commit_message>
<xml_diff>
--- a/deliverables/Football stability.pptx
+++ b/deliverables/Football stability.pptx
@@ -2,14 +2,14 @@
 <file path=ppt/presentation.xml><?xml version="1.0" encoding="utf-8"?>
 <p:presentation xmlns:p="http://schemas.openxmlformats.org/presentationml/2006/main">
   <p:sldMasterIdLst>
-    <p:sldMasterId xmlns:r="http://schemas.openxmlformats.org/officeDocument/2006/relationships" id="2147483648" r:id="R411d99f794de4ddf"/>
+    <p:sldMasterId xmlns:r="http://schemas.openxmlformats.org/officeDocument/2006/relationships" id="2147483648" r:id="Ree5de390db304c31"/>
   </p:sldMasterIdLst>
   <p:notesMasterIdLst>
-    <p:notesMasterId xmlns:r="http://schemas.openxmlformats.org/officeDocument/2006/relationships" r:id="Rae07c37592004dad"/>
+    <p:notesMasterId xmlns:r="http://schemas.openxmlformats.org/officeDocument/2006/relationships" r:id="R49980c3b292a4ed7"/>
   </p:notesMasterIdLst>
   <p:sldIdLst>
-    <p:sldId xmlns:r="http://schemas.openxmlformats.org/officeDocument/2006/relationships" id="256" r:id="R91e87c9717414b13"/>
-    <p:sldId xmlns:r="http://schemas.openxmlformats.org/officeDocument/2006/relationships" id="257" r:id="Rdea1646dbcdf4404"/>
+    <p:sldId xmlns:r="http://schemas.openxmlformats.org/officeDocument/2006/relationships" id="256" r:id="Rafd52f288e7b484f"/>
+    <p:sldId xmlns:r="http://schemas.openxmlformats.org/officeDocument/2006/relationships" id="257" r:id="Rd4d430f658ae47c3"/>
   </p:sldIdLst>
   <p:sldSz cx="12192000" cy="6858000"/>
   <p:notesSz cx="6858000" cy="9144000"/>
@@ -581,7 +581,7 @@
   </p:cSld>
   <p:clrMap bg1="lt1" tx1="dk1" bg2="lt2" tx2="dk2" accent1="accent1" accent2="accent2" accent3="accent3" accent4="accent4" accent5="accent5" accent6="accent6" hlink="hlink" folHlink="folHlink"/>
   <p:sldLayoutIdLst>
-    <p:sldLayoutId xmlns:r="http://schemas.openxmlformats.org/officeDocument/2006/relationships" id="2147483649" r:id="Rbffb494b9fc44a87"/>
+    <p:sldLayoutId xmlns:r="http://schemas.openxmlformats.org/officeDocument/2006/relationships" id="2147483649" r:id="Rd653b786f089438d"/>
   </p:sldLayoutIdLst>
   <p:txStyles>
     <p:titleStyle>
@@ -1123,18 +1123,18 @@
             <c:v>Logistic</c:v>
           </c:tx>
           <c:spPr>
-            <a:ln xmlns:a="http://schemas.openxmlformats.org/drawingml/2006/main" w="28575">
+            <a:ln xmlns:a="http://schemas.openxmlformats.org/drawingml/2006/main" w="38100">
               <a:solidFill>
-                <a:srgbClr val="184E38"/>
+                <a:srgbClr val="1B4A38"/>
               </a:solidFill>
             </a:ln>
           </c:spPr>
           <c:marker>
             <c:symbol val="circle"/>
-            <c:size val="8"/>
+            <c:size val="9"/>
             <c:spPr>
               <a:solidFill xmlns:a="http://schemas.openxmlformats.org/drawingml/2006/main">
-                <a:srgbClr val="184E38"/>
+                <a:srgbClr val="1B4A38"/>
               </a:solidFill>
             </c:spPr>
           </c:marker>
@@ -1183,18 +1183,18 @@
             <c:v>Random Forest</c:v>
           </c:tx>
           <c:spPr>
-            <a:ln xmlns:a="http://schemas.openxmlformats.org/drawingml/2006/main" w="28575">
+            <a:ln xmlns:a="http://schemas.openxmlformats.org/drawingml/2006/main" w="23813">
               <a:solidFill>
-                <a:srgbClr val="A98039"/>
+                <a:srgbClr val="B58E4F"/>
               </a:solidFill>
             </a:ln>
           </c:spPr>
           <c:marker>
-            <c:symbol val="circle"/>
-            <c:size val="8"/>
+            <c:symbol val="square"/>
+            <c:size val="7"/>
             <c:spPr>
               <a:solidFill xmlns:a="http://schemas.openxmlformats.org/drawingml/2006/main">
-                <a:srgbClr val="A98039"/>
+                <a:srgbClr val="B58E4F"/>
               </a:solidFill>
             </c:spPr>
           </c:marker>
@@ -1243,18 +1243,18 @@
             <c:v>XGBoost</c:v>
           </c:tx>
           <c:spPr>
-            <a:ln xmlns:a="http://schemas.openxmlformats.org/drawingml/2006/main" w="28575">
+            <a:ln xmlns:a="http://schemas.openxmlformats.org/drawingml/2006/main" w="23813">
               <a:solidFill>
-                <a:srgbClr val="627892"/>
+                <a:srgbClr val="82948A"/>
               </a:solidFill>
             </a:ln>
           </c:spPr>
           <c:marker>
-            <c:symbol val="circle"/>
-            <c:size val="8"/>
+            <c:symbol val="diamond"/>
+            <c:size val="7"/>
             <c:spPr>
               <a:solidFill xmlns:a="http://schemas.openxmlformats.org/drawingml/2006/main">
-                <a:srgbClr val="627892"/>
+                <a:srgbClr val="82948A"/>
               </a:solidFill>
             </c:spPr>
           </c:marker>
@@ -1329,47 +1329,14 @@
         </c:scaling>
         <c:delete val="0"/>
         <c:axPos val="b"/>
-        <c:title>
-          <c:tx>
-            <c:rich>
-              <a:bodyPr xmlns:a="http://schemas.openxmlformats.org/drawingml/2006/main"/>
-              <a:lstStyle xmlns:a="http://schemas.openxmlformats.org/drawingml/2006/main"/>
-              <a:p xmlns:a="http://schemas.openxmlformats.org/drawingml/2006/main">
-                <a:r>
-                  <a:rPr>
-                    <a:latin typeface="Helvetica Neue"/>
-                    <a:ea typeface="Helvetica Neue"/>
-                    <a:cs typeface="Helvetica Neue"/>
-                  </a:rPr>
-                  <a:t>Test season</a:t>
-                </a:r>
-              </a:p>
-            </c:rich>
-          </c:tx>
-          <c:overlay val="0"/>
-          <c:txPr>
-            <a:bodyPr xmlns:a="http://schemas.openxmlformats.org/drawingml/2006/main" anchorCtr="1"/>
-            <a:lstStyle xmlns:a="http://schemas.openxmlformats.org/drawingml/2006/main"/>
-            <a:p xmlns:a="http://schemas.openxmlformats.org/drawingml/2006/main">
-              <a:pPr>
-                <a:defRPr>
-                  <a:latin typeface="Helvetica Neue"/>
-                  <a:ea typeface="Helvetica Neue"/>
-                  <a:cs typeface="Helvetica Neue"/>
-                </a:defRPr>
-              </a:pPr>
-            </a:p>
-          </c:txPr>
-        </c:title>
         <c:numFmt formatCode="General"/>
         <c:majorTickMark val="none"/>
         <c:minorTickMark val="none"/>
         <c:spPr>
-          <a:ln xmlns:a="http://schemas.openxmlformats.org/drawingml/2006/main" w="9525">
+          <a:ln xmlns:a="http://schemas.openxmlformats.org/drawingml/2006/main" w="0">
             <a:solidFill>
-              <a:srgbClr val="D4D4D4"/>
+              <a:srgbClr val="F7F5F0"/>
             </a:solidFill>
-            <a:prstDash val="solid"/>
           </a:ln>
         </c:spPr>
         <c:txPr>
@@ -1377,9 +1344,9 @@
           <a:lstStyle xmlns:a="http://schemas.openxmlformats.org/drawingml/2006/main"/>
           <a:p xmlns:a="http://schemas.openxmlformats.org/drawingml/2006/main">
             <a:pPr>
-              <a:defRPr>
-                <a:solidFill>
-                  <a:srgbClr val="666666"/>
+              <a:defRPr sz="1350">
+                <a:solidFill>
+                  <a:srgbClr val="637267"/>
                 </a:solidFill>
                 <a:latin typeface="Helvetica Neue"/>
                 <a:ea typeface="Helvetica Neue"/>
@@ -1399,30 +1366,182 @@
         </c:scaling>
         <c:delete val="0"/>
         <c:axPos val="l"/>
-        <c:title>
+        <c:majorGridlines>
+          <c:spPr>
+            <a:ln xmlns:a="http://schemas.openxmlformats.org/drawingml/2006/main" w="9525">
+              <a:solidFill>
+                <a:srgbClr val="E0E3DB"/>
+              </a:solidFill>
+            </a:ln>
+          </c:spPr>
+        </c:majorGridlines>
+        <c:numFmt formatCode="0.00"/>
+        <c:majorTickMark val="none"/>
+        <c:minorTickMark val="none"/>
+        <c:spPr>
+          <a:ln xmlns:a="http://schemas.openxmlformats.org/drawingml/2006/main" w="0">
+            <a:solidFill>
+              <a:srgbClr val="F7F5F0"/>
+            </a:solidFill>
+          </a:ln>
+        </c:spPr>
+        <c:txPr>
+          <a:bodyPr xmlns:a="http://schemas.openxmlformats.org/drawingml/2006/main" anchorCtr="1"/>
+          <a:lstStyle xmlns:a="http://schemas.openxmlformats.org/drawingml/2006/main"/>
+          <a:p xmlns:a="http://schemas.openxmlformats.org/drawingml/2006/main">
+            <a:pPr>
+              <a:defRPr sz="1350">
+                <a:solidFill>
+                  <a:srgbClr val="637267"/>
+                </a:solidFill>
+                <a:latin typeface="Helvetica Neue"/>
+                <a:ea typeface="Helvetica Neue"/>
+                <a:cs typeface="Helvetica Neue"/>
+              </a:defRPr>
+            </a:pPr>
+          </a:p>
+        </c:txPr>
+        <c:crossAx val="48650112"/>
+        <c:crossBetween val="between"/>
+        <c:majorUnit val="0.05"/>
+      </c:valAx>
+      <c:spPr>
+        <a:solidFill xmlns:a="http://schemas.openxmlformats.org/drawingml/2006/main">
+          <a:srgbClr val="F7F5F0"/>
+        </a:solidFill>
+        <a:ln xmlns:a="http://schemas.openxmlformats.org/drawingml/2006/main" w="0">
+          <a:solidFill>
+            <a:srgbClr val="F7F5F0"/>
+          </a:solidFill>
+        </a:ln>
+      </c:spPr>
+    </c:plotArea>
+    <c:legend>
+      <c:legendPos val="b"/>
+      <c:overlay val="0"/>
+      <c:txPr>
+        <a:bodyPr xmlns:a="http://schemas.openxmlformats.org/drawingml/2006/main" anchorCtr="1"/>
+        <a:lstStyle xmlns:a="http://schemas.openxmlformats.org/drawingml/2006/main"/>
+        <a:p xmlns:a="http://schemas.openxmlformats.org/drawingml/2006/main">
+          <a:pPr>
+            <a:defRPr sz="1500">
+              <a:solidFill>
+                <a:srgbClr val="637267"/>
+              </a:solidFill>
+              <a:latin typeface="Helvetica Neue"/>
+              <a:ea typeface="Helvetica Neue"/>
+              <a:cs typeface="Helvetica Neue"/>
+            </a:defRPr>
+          </a:pPr>
+        </a:p>
+      </c:txPr>
+    </c:legend>
+    <c:plotVisOnly val="1"/>
+  </c:chart>
+  <c:spPr>
+    <a:solidFill xmlns:a="http://schemas.openxmlformats.org/drawingml/2006/main">
+      <a:srgbClr val="F7F5F0"/>
+    </a:solidFill>
+    <a:ln xmlns:a="http://schemas.openxmlformats.org/drawingml/2006/main" w="0">
+      <a:solidFill>
+        <a:srgbClr val="F7F5F0"/>
+      </a:solidFill>
+    </a:ln>
+  </c:spPr>
+  <c:externalData r:id="rIdChartSnapshot1">
+    <c:autoUpdate val="0"/>
+  </c:externalData>
+</c:chartSpace>
+</file>
+
+<file path=ppt/slides/charts/chart2.xml><?xml version="1.0" encoding="utf-8"?>
+<c:chartSpace xmlns:c="http://schemas.openxmlformats.org/drawingml/2006/chart" xmlns:r="http://schemas.openxmlformats.org/officeDocument/2006/relationships">
+  <c:lang val="en-US"/>
+  <c:chart>
+    <c:plotArea>
+      <c:barChart>
+        <c:barDir val="bar"/>
+        <c:grouping val="clustered"/>
+        <c:varyColors val="0"/>
+        <c:ser>
+          <c:idx val="0"/>
+          <c:order val="0"/>
           <c:tx>
-            <c:rich>
-              <a:bodyPr xmlns:a="http://schemas.openxmlformats.org/drawingml/2006/main"/>
-              <a:lstStyle xmlns:a="http://schemas.openxmlformats.org/drawingml/2006/main"/>
-              <a:p xmlns:a="http://schemas.openxmlformats.org/drawingml/2006/main">
-                <a:r>
-                  <a:rPr>
-                    <a:latin typeface="Helvetica Neue"/>
-                    <a:ea typeface="Helvetica Neue"/>
-                    <a:cs typeface="Helvetica Neue"/>
-                  </a:rPr>
-                  <a:t>ROC AUC</a:t>
-                </a:r>
-              </a:p>
-            </c:rich>
+            <c:v>Score change</c:v>
           </c:tx>
-          <c:overlay val="0"/>
+          <c:dPt>
+            <c:idx val="0"/>
+            <c:invertIfNegative val="0"/>
+            <c:spPr>
+              <a:solidFill xmlns:a="http://schemas.openxmlformats.org/drawingml/2006/main">
+                <a:srgbClr val="D0E2D3"/>
+              </a:solidFill>
+            </c:spPr>
+          </c:dPt>
+          <c:dPt>
+            <c:idx val="1"/>
+            <c:invertIfNegative val="0"/>
+            <c:spPr>
+              <a:solidFill xmlns:a="http://schemas.openxmlformats.org/drawingml/2006/main">
+                <a:srgbClr val="97B49F"/>
+              </a:solidFill>
+            </c:spPr>
+          </c:dPt>
+          <c:dPt>
+            <c:idx val="2"/>
+            <c:invertIfNegative val="0"/>
+            <c:spPr>
+              <a:solidFill xmlns:a="http://schemas.openxmlformats.org/drawingml/2006/main">
+                <a:srgbClr val="6F967F"/>
+              </a:solidFill>
+            </c:spPr>
+          </c:dPt>
+          <c:cat>
+            <c:strRef>
+              <c:f>'Chart Data'!$A$2:$A$4</c:f>
+              <c:strCache>
+                <c:ptCount val="3"/>
+                <c:pt idx="0">
+                  <c:v>Logistic</c:v>
+                </c:pt>
+                <c:pt idx="1">
+                  <c:v>Random Forest</c:v>
+                </c:pt>
+                <c:pt idx="2">
+                  <c:v>XGBoost</c:v>
+                </c:pt>
+              </c:strCache>
+            </c:strRef>
+          </c:cat>
+          <c:val>
+            <c:numRef>
+              <c:f>'Chart Data'!$B$2:$B$4</c:f>
+              <c:numCache>
+                <c:formatCode>0.00</c:formatCode>
+                <c:ptCount val="3"/>
+                <c:pt idx="0">
+                  <c:v>0.1</c:v>
+                </c:pt>
+                <c:pt idx="1">
+                  <c:v>0.23</c:v>
+                </c:pt>
+                <c:pt idx="2">
+                  <c:v>0.37</c:v>
+                </c:pt>
+              </c:numCache>
+            </c:numRef>
+          </c:val>
+        </c:ser>
+        <c:dLbls>
           <c:txPr>
             <a:bodyPr xmlns:a="http://schemas.openxmlformats.org/drawingml/2006/main" anchorCtr="1"/>
             <a:lstStyle xmlns:a="http://schemas.openxmlformats.org/drawingml/2006/main"/>
             <a:p xmlns:a="http://schemas.openxmlformats.org/drawingml/2006/main">
               <a:pPr>
-                <a:defRPr>
+                <a:defRPr sz="1950">
+                  <a:solidFill>
+                    <a:srgbClr val="F7F5F0"/>
+                  </a:solidFill>
                   <a:latin typeface="Helvetica Neue"/>
                   <a:ea typeface="Helvetica Neue"/>
                   <a:cs typeface="Helvetica Neue"/>
@@ -1430,16 +1549,34 @@
               </a:pPr>
             </a:p>
           </c:txPr>
-        </c:title>
-        <c:numFmt formatCode="0.00"/>
+          <c:dLblPos val="outEnd"/>
+          <c:showLegendKey val="0"/>
+          <c:showVal val="1"/>
+          <c:showCatName val="0"/>
+          <c:showSerName val="0"/>
+          <c:showPercent val="0"/>
+          <c:showBubbleSize val="0"/>
+          <c:showLeaderLines val="0"/>
+        </c:dLbls>
+        <c:gapWidth val="110"/>
+        <c:axId val="48650112"/>
+        <c:axId val="48672768"/>
+      </c:barChart>
+      <c:catAx>
+        <c:axId val="48650112"/>
+        <c:scaling>
+          <c:orientation val="minMax"/>
+        </c:scaling>
+        <c:delete val="0"/>
+        <c:axPos val="l"/>
+        <c:numFmt formatCode="General"/>
         <c:majorTickMark val="none"/>
         <c:minorTickMark val="none"/>
         <c:spPr>
-          <a:ln xmlns:a="http://schemas.openxmlformats.org/drawingml/2006/main" w="9525">
+          <a:ln xmlns:a="http://schemas.openxmlformats.org/drawingml/2006/main" w="0">
             <a:solidFill>
-              <a:srgbClr val="D4D4D4"/>
+              <a:srgbClr val="173F31"/>
             </a:solidFill>
-            <a:prstDash val="solid"/>
           </a:ln>
         </c:spPr>
         <c:txPr>
@@ -1447,9 +1584,44 @@
           <a:lstStyle xmlns:a="http://schemas.openxmlformats.org/drawingml/2006/main"/>
           <a:p xmlns:a="http://schemas.openxmlformats.org/drawingml/2006/main">
             <a:pPr>
-              <a:defRPr>
-                <a:solidFill>
-                  <a:srgbClr val="666666"/>
+              <a:defRPr sz="1650">
+                <a:solidFill>
+                  <a:srgbClr val="F7F5F0"/>
+                </a:solidFill>
+                <a:latin typeface="Helvetica Neue"/>
+                <a:ea typeface="Helvetica Neue"/>
+                <a:cs typeface="Helvetica Neue"/>
+              </a:defRPr>
+            </a:pPr>
+          </a:p>
+        </c:txPr>
+        <c:crossAx val="48672768"/>
+      </c:catAx>
+      <c:valAx>
+        <c:axId val="48672768"/>
+        <c:scaling>
+          <c:orientation val="minMax"/>
+        </c:scaling>
+        <c:delete val="0"/>
+        <c:axPos val="b"/>
+        <c:numFmt formatCode="General"/>
+        <c:majorTickMark val="none"/>
+        <c:minorTickMark val="none"/>
+        <c:spPr>
+          <a:ln xmlns:a="http://schemas.openxmlformats.org/drawingml/2006/main" w="0">
+            <a:solidFill>
+              <a:srgbClr val="173F31"/>
+            </a:solidFill>
+          </a:ln>
+        </c:spPr>
+        <c:txPr>
+          <a:bodyPr xmlns:a="http://schemas.openxmlformats.org/drawingml/2006/main" anchorCtr="1"/>
+          <a:lstStyle xmlns:a="http://schemas.openxmlformats.org/drawingml/2006/main"/>
+          <a:p xmlns:a="http://schemas.openxmlformats.org/drawingml/2006/main">
+            <a:pPr>
+              <a:defRPr sz="1650">
+                <a:solidFill>
+                  <a:srgbClr val="F7F5F0"/>
                 </a:solidFill>
                 <a:latin typeface="Helvetica Neue"/>
                 <a:ea typeface="Helvetica Neue"/>
@@ -1463,33 +1635,26 @@
       </c:valAx>
       <c:spPr>
         <a:solidFill xmlns:a="http://schemas.openxmlformats.org/drawingml/2006/main">
-          <a:srgbClr val="F7F6F0"/>
+          <a:srgbClr val="173F31"/>
         </a:solidFill>
+        <a:ln xmlns:a="http://schemas.openxmlformats.org/drawingml/2006/main" w="0">
+          <a:solidFill>
+            <a:srgbClr val="173F31"/>
+          </a:solidFill>
+        </a:ln>
       </c:spPr>
     </c:plotArea>
-    <c:legend>
-      <c:legendPos val="b"/>
-      <c:overlay val="0"/>
-      <c:txPr>
-        <a:bodyPr xmlns:a="http://schemas.openxmlformats.org/drawingml/2006/main" anchorCtr="1"/>
-        <a:lstStyle xmlns:a="http://schemas.openxmlformats.org/drawingml/2006/main"/>
-        <a:p xmlns:a="http://schemas.openxmlformats.org/drawingml/2006/main">
-          <a:pPr>
-            <a:defRPr sz="1425">
-              <a:latin typeface="Helvetica Neue"/>
-              <a:ea typeface="Helvetica Neue"/>
-              <a:cs typeface="Helvetica Neue"/>
-            </a:defRPr>
-          </a:pPr>
-        </a:p>
-      </c:txPr>
-    </c:legend>
     <c:plotVisOnly val="1"/>
   </c:chart>
   <c:spPr>
     <a:solidFill xmlns:a="http://schemas.openxmlformats.org/drawingml/2006/main">
-      <a:srgbClr val="F7F6F0"/>
+      <a:srgbClr val="173F31"/>
     </a:solidFill>
+    <a:ln xmlns:a="http://schemas.openxmlformats.org/drawingml/2006/main" w="0">
+      <a:solidFill>
+        <a:srgbClr val="173F31"/>
+      </a:solidFill>
+    </a:ln>
   </c:spPr>
   <c:externalData r:id="rIdChartSnapshot1">
     <c:autoUpdate val="0"/>
@@ -1503,7 +1668,7 @@
     <p:bg>
       <p:bgPr>
         <a:solidFill xmlns:a="http://schemas.openxmlformats.org/drawingml/2006/main">
-          <a:srgbClr val="F7F6F0"/>
+          <a:srgbClr val="F7F5F0"/>
         </a:solidFill>
       </p:bgPr>
     </p:bg>
@@ -1518,10 +1683,10 @@
       </p:grpSpPr>
       <p:sp>
         <p:nvSpPr>
-          <p:cNvPr id="11" name="">
+          <p:cNvPr id="13" name="">
             <a:extLst xmlns:a="http://schemas.openxmlformats.org/drawingml/2006/main">
               <a:ext uri="{FF2B5EF4-FFF2-40B4-BE49-F238E27FC236}">
-                <a16:creationId xmlns:a16="http://schemas.microsoft.com/office/drawing/2014/main" id="{CBB3320D-A4B2-40FC-9E25-C74886CD1379}"/>
+                <a16:creationId xmlns:a16="http://schemas.microsoft.com/office/drawing/2014/main" id="{EF09187B-207B-484B-B2DF-7184BE94868C}"/>
               </a:ext>
             </a:extLst>
           </p:cNvPr>
@@ -1532,8 +1697,8 @@
         </p:nvSpPr>
         <p:spPr>
           <a:xfrm xmlns:a="http://schemas.openxmlformats.org/drawingml/2006/main">
-            <a:off x="590550" y="304800"/>
-            <a:ext cx="10001250" cy="247650"/>
+            <a:off x="609600" y="352425"/>
+            <a:ext cx="9525000" cy="285750"/>
           </a:xfrm>
           <a:prstGeom xmlns:a="http://schemas.openxmlformats.org/drawingml/2006/main" prst="rect">
             <a:avLst/>
@@ -1550,9 +1715,9 @@
           <a:lstStyle xmlns:a="http://schemas.openxmlformats.org/drawingml/2006/main"/>
           <a:p xmlns:a="http://schemas.openxmlformats.org/drawingml/2006/main">
             <a:pPr>
-              <a:defRPr sz="1200" b="0">
-                <a:solidFill>
-                  <a:srgbClr val="617266"/>
+              <a:defRPr sz="1200" b="1">
+                <a:solidFill>
+                  <a:srgbClr val="637267"/>
                 </a:solidFill>
                 <a:latin typeface="Helvetica Neue"/>
                 <a:ea typeface="Helvetica Neue"/>
@@ -1560,15 +1725,15 @@
               </a:defRPr>
             </a:pPr>
             <a:r>
-              <a:rPr sz="1200" b="0">
-                <a:solidFill>
-                  <a:srgbClr val="617266"/>
+              <a:rPr sz="1200" b="1">
+                <a:solidFill>
+                  <a:srgbClr val="637267"/>
                 </a:solidFill>
                 <a:latin typeface="Helvetica Neue"/>
                 <a:ea typeface="Helvetica Neue"/>
                 <a:cs typeface="Helvetica Neue"/>
               </a:rPr>
-              <a:t>FOOTBALL RECRUITMENT SCORING</a:t>
+              <a:t>FOOTBALL RECRUITMENT</a:t>
             </a:r>
           </a:p>
         </p:txBody>
@@ -1578,7 +1743,7 @@
           <p:cNvPr id="2" name="">
             <a:extLst xmlns:a="http://schemas.openxmlformats.org/drawingml/2006/main">
               <a:ext uri="{FF2B5EF4-FFF2-40B4-BE49-F238E27FC236}">
-                <a16:creationId xmlns:a16="http://schemas.microsoft.com/office/drawing/2014/main" id="{478B258F-1D92-4F35-97F4-BF2EEC28921B}"/>
+                <a16:creationId xmlns:a16="http://schemas.microsoft.com/office/drawing/2014/main" id="{5A1BA1D2-BC2F-4E41-A48C-7A81FCC996C6}"/>
               </a:ext>
             </a:extLst>
           </p:cNvPr>
@@ -1589,8 +1754,8 @@
         </p:nvSpPr>
         <p:spPr>
           <a:xfrm xmlns:a="http://schemas.openxmlformats.org/drawingml/2006/main">
-            <a:off x="590550" y="828675"/>
-            <a:ext cx="11049000" cy="809625"/>
+            <a:off x="11049000" y="314325"/>
+            <a:ext cx="666750" cy="400050"/>
           </a:xfrm>
           <a:prstGeom xmlns:a="http://schemas.openxmlformats.org/drawingml/2006/main" prst="rect">
             <a:avLst/>
@@ -1607,25 +1772,25 @@
           <a:lstStyle xmlns:a="http://schemas.openxmlformats.org/drawingml/2006/main"/>
           <a:p xmlns:a="http://schemas.openxmlformats.org/drawingml/2006/main">
             <a:pPr>
-              <a:defRPr sz="3450" b="0">
-                <a:solidFill>
-                  <a:srgbClr val="203F30"/>
-                </a:solidFill>
-                <a:latin typeface="Helvetica Neue"/>
-                <a:ea typeface="Helvetica Neue"/>
-                <a:cs typeface="Helvetica Neue"/>
+              <a:defRPr sz="2100" b="0">
+                <a:solidFill>
+                  <a:srgbClr val="1B4A38"/>
+                </a:solidFill>
+                <a:latin typeface="Georgia"/>
+                <a:ea typeface="Georgia"/>
+                <a:cs typeface="Georgia"/>
               </a:defRPr>
             </a:pPr>
             <a:r>
-              <a:rPr sz="3450" b="0">
-                <a:solidFill>
-                  <a:srgbClr val="203F30"/>
-                </a:solidFill>
-                <a:latin typeface="Helvetica Neue"/>
-                <a:ea typeface="Helvetica Neue"/>
-                <a:cs typeface="Helvetica Neue"/>
+              <a:rPr sz="2100" b="0">
+                <a:solidFill>
+                  <a:srgbClr val="1B4A38"/>
+                </a:solidFill>
+                <a:latin typeface="Georgia"/>
+                <a:ea typeface="Georgia"/>
+                <a:cs typeface="Georgia"/>
               </a:rPr>
-              <a:t>Performance across future seasons</a:t>
+              <a:t>01</a:t>
             </a:r>
           </a:p>
         </p:txBody>
@@ -1635,7 +1800,7 @@
           <p:cNvPr id="3" name="">
             <a:extLst xmlns:a="http://schemas.openxmlformats.org/drawingml/2006/main">
               <a:ext uri="{FF2B5EF4-FFF2-40B4-BE49-F238E27FC236}">
-                <a16:creationId xmlns:a16="http://schemas.microsoft.com/office/drawing/2014/main" id="{9EBD6023-D339-4010-9767-17077BF97036}"/>
+                <a16:creationId xmlns:a16="http://schemas.microsoft.com/office/drawing/2014/main" id="{1EB127B0-FE88-4F25-B8EC-9A34C243988E}"/>
               </a:ext>
             </a:extLst>
           </p:cNvPr>
@@ -1646,8 +1811,446 @@
         </p:nvSpPr>
         <p:spPr>
           <a:xfrm xmlns:a="http://schemas.openxmlformats.org/drawingml/2006/main">
-            <a:off x="11049000" y="6286500"/>
-            <a:ext cx="571500" cy="238125"/>
+            <a:off x="571500" y="981075"/>
+            <a:ext cx="11049000" cy="876300"/>
+          </a:xfrm>
+          <a:prstGeom xmlns:a="http://schemas.openxmlformats.org/drawingml/2006/main" prst="rect">
+            <a:avLst/>
+          </a:prstGeom>
+          <a:noFill xmlns:a="http://schemas.openxmlformats.org/drawingml/2006/main"/>
+          <a:ln xmlns:a="http://schemas.openxmlformats.org/drawingml/2006/main" w="0">
+            <a:noFill/>
+          </a:ln>
+        </p:spPr>
+        <p:txBody>
+          <a:bodyPr xmlns:a="http://schemas.openxmlformats.org/drawingml/2006/main">
+            <a:noAutofit/>
+          </a:bodyPr>
+          <a:lstStyle xmlns:a="http://schemas.openxmlformats.org/drawingml/2006/main"/>
+          <a:p xmlns:a="http://schemas.openxmlformats.org/drawingml/2006/main">
+            <a:pPr>
+              <a:defRPr sz="4650" b="0">
+                <a:solidFill>
+                  <a:srgbClr val="1B4A38"/>
+                </a:solidFill>
+                <a:latin typeface="Georgia"/>
+                <a:ea typeface="Georgia"/>
+                <a:cs typeface="Georgia"/>
+              </a:defRPr>
+            </a:pPr>
+            <a:r>
+              <a:rPr sz="4650" b="0">
+                <a:solidFill>
+                  <a:srgbClr val="1B4A38"/>
+                </a:solidFill>
+                <a:latin typeface="Georgia"/>
+                <a:ea typeface="Georgia"/>
+                <a:cs typeface="Georgia"/>
+              </a:rPr>
+              <a:t>Performance across seasons</a:t>
+            </a:r>
+          </a:p>
+        </p:txBody>
+      </p:sp>
+      <p:sp>
+        <p:nvSpPr>
+          <p:cNvPr id="4" name="">
+            <a:extLst xmlns:a="http://schemas.openxmlformats.org/drawingml/2006/main">
+              <a:ext uri="{FF2B5EF4-FFF2-40B4-BE49-F238E27FC236}">
+                <a16:creationId xmlns:a16="http://schemas.microsoft.com/office/drawing/2014/main" id="{8CF90081-83A8-4821-A9B1-03802ECEF265}"/>
+              </a:ext>
+            </a:extLst>
+          </p:cNvPr>
+          <p:cNvSpPr>
+            <a:spLocks xmlns:a="http://schemas.openxmlformats.org/drawingml/2006/main" noGrp="1"/>
+          </p:cNvSpPr>
+          <p:nvPr/>
+        </p:nvSpPr>
+        <p:spPr>
+          <a:xfrm xmlns:a="http://schemas.openxmlformats.org/drawingml/2006/main">
+            <a:off x="619125" y="1905000"/>
+            <a:ext cx="10572750" cy="400050"/>
+          </a:xfrm>
+          <a:prstGeom xmlns:a="http://schemas.openxmlformats.org/drawingml/2006/main" prst="rect">
+            <a:avLst/>
+          </a:prstGeom>
+          <a:noFill xmlns:a="http://schemas.openxmlformats.org/drawingml/2006/main"/>
+          <a:ln xmlns:a="http://schemas.openxmlformats.org/drawingml/2006/main" w="0">
+            <a:noFill/>
+          </a:ln>
+        </p:spPr>
+        <p:txBody>
+          <a:bodyPr xmlns:a="http://schemas.openxmlformats.org/drawingml/2006/main">
+            <a:noAutofit/>
+          </a:bodyPr>
+          <a:lstStyle xmlns:a="http://schemas.openxmlformats.org/drawingml/2006/main"/>
+          <a:p xmlns:a="http://schemas.openxmlformats.org/drawingml/2006/main">
+            <a:pPr>
+              <a:defRPr sz="1875" b="0">
+                <a:solidFill>
+                  <a:srgbClr val="637267"/>
+                </a:solidFill>
+                <a:latin typeface="Helvetica Neue"/>
+                <a:ea typeface="Helvetica Neue"/>
+                <a:cs typeface="Helvetica Neue"/>
+              </a:defRPr>
+            </a:pPr>
+            <a:r>
+              <a:rPr sz="1875" b="0">
+                <a:solidFill>
+                  <a:srgbClr val="637267"/>
+                </a:solidFill>
+                <a:latin typeface="Helvetica Neue"/>
+                <a:ea typeface="Helvetica Neue"/>
+                <a:cs typeface="Helvetica Neue"/>
+              </a:rPr>
+              <a:t>Nine leagues, with 2,057 observations in the test set.</a:t>
+            </a:r>
+          </a:p>
+        </p:txBody>
+      </p:sp>
+      <p:sp>
+        <p:nvSpPr>
+          <p:cNvPr id="5" name="">
+            <a:extLst xmlns:a="http://schemas.openxmlformats.org/drawingml/2006/main">
+              <a:ext uri="{FF2B5EF4-FFF2-40B4-BE49-F238E27FC236}">
+                <a16:creationId xmlns:a16="http://schemas.microsoft.com/office/drawing/2014/main" id="{9463FC83-963F-4A2A-8E0D-131E6EAB99C1}"/>
+              </a:ext>
+            </a:extLst>
+          </p:cNvPr>
+          <p:cNvSpPr>
+            <a:spLocks xmlns:a="http://schemas.openxmlformats.org/drawingml/2006/main" noGrp="1"/>
+          </p:cNvSpPr>
+          <p:nvPr/>
+        </p:nvSpPr>
+        <p:spPr>
+          <a:xfrm xmlns:a="http://schemas.openxmlformats.org/drawingml/2006/main">
+            <a:off x="628650" y="2867025"/>
+            <a:ext cx="3381375" cy="285750"/>
+          </a:xfrm>
+          <a:prstGeom xmlns:a="http://schemas.openxmlformats.org/drawingml/2006/main" prst="rect">
+            <a:avLst/>
+          </a:prstGeom>
+          <a:noFill xmlns:a="http://schemas.openxmlformats.org/drawingml/2006/main"/>
+          <a:ln xmlns:a="http://schemas.openxmlformats.org/drawingml/2006/main" w="0">
+            <a:noFill/>
+          </a:ln>
+        </p:spPr>
+        <p:txBody>
+          <a:bodyPr xmlns:a="http://schemas.openxmlformats.org/drawingml/2006/main">
+            <a:noAutofit/>
+          </a:bodyPr>
+          <a:lstStyle xmlns:a="http://schemas.openxmlformats.org/drawingml/2006/main"/>
+          <a:p xmlns:a="http://schemas.openxmlformats.org/drawingml/2006/main">
+            <a:pPr>
+              <a:defRPr sz="1200" b="1">
+                <a:solidFill>
+                  <a:srgbClr val="1B4A38"/>
+                </a:solidFill>
+                <a:latin typeface="Helvetica Neue"/>
+                <a:ea typeface="Helvetica Neue"/>
+                <a:cs typeface="Helvetica Neue"/>
+              </a:defRPr>
+            </a:pPr>
+            <a:r>
+              <a:rPr sz="1200" b="1">
+                <a:solidFill>
+                  <a:srgbClr val="1B4A38"/>
+                </a:solidFill>
+                <a:latin typeface="Helvetica Neue"/>
+                <a:ea typeface="Helvetica Neue"/>
+                <a:cs typeface="Helvetica Neue"/>
+              </a:rPr>
+              <a:t>LOGISTIC REGRESSION</a:t>
+            </a:r>
+          </a:p>
+        </p:txBody>
+      </p:sp>
+      <p:sp>
+        <p:nvSpPr>
+          <p:cNvPr id="6" name="">
+            <a:extLst xmlns:a="http://schemas.openxmlformats.org/drawingml/2006/main">
+              <a:ext uri="{FF2B5EF4-FFF2-40B4-BE49-F238E27FC236}">
+                <a16:creationId xmlns:a16="http://schemas.microsoft.com/office/drawing/2014/main" id="{4561DBD0-2D67-4625-9F1A-A9C33D32B840}"/>
+              </a:ext>
+            </a:extLst>
+          </p:cNvPr>
+          <p:cNvSpPr>
+            <a:spLocks xmlns:a="http://schemas.openxmlformats.org/drawingml/2006/main" noGrp="1"/>
+          </p:cNvSpPr>
+          <p:nvPr/>
+        </p:nvSpPr>
+        <p:spPr>
+          <a:xfrm xmlns:a="http://schemas.openxmlformats.org/drawingml/2006/main">
+            <a:off x="533400" y="3181350"/>
+            <a:ext cx="3467100" cy="1209675"/>
+          </a:xfrm>
+          <a:prstGeom xmlns:a="http://schemas.openxmlformats.org/drawingml/2006/main" prst="rect">
+            <a:avLst/>
+          </a:prstGeom>
+          <a:noFill xmlns:a="http://schemas.openxmlformats.org/drawingml/2006/main"/>
+          <a:ln xmlns:a="http://schemas.openxmlformats.org/drawingml/2006/main" w="0">
+            <a:noFill/>
+          </a:ln>
+        </p:spPr>
+        <p:txBody>
+          <a:bodyPr xmlns:a="http://schemas.openxmlformats.org/drawingml/2006/main">
+            <a:noAutofit/>
+          </a:bodyPr>
+          <a:lstStyle xmlns:a="http://schemas.openxmlformats.org/drawingml/2006/main"/>
+          <a:p xmlns:a="http://schemas.openxmlformats.org/drawingml/2006/main">
+            <a:pPr>
+              <a:defRPr sz="7875" b="0">
+                <a:solidFill>
+                  <a:srgbClr val="1B4A38"/>
+                </a:solidFill>
+                <a:latin typeface="Georgia"/>
+                <a:ea typeface="Georgia"/>
+                <a:cs typeface="Georgia"/>
+              </a:defRPr>
+            </a:pPr>
+            <a:r>
+              <a:rPr sz="7875" b="0">
+                <a:solidFill>
+                  <a:srgbClr val="1B4A38"/>
+                </a:solidFill>
+                <a:latin typeface="Georgia"/>
+                <a:ea typeface="Georgia"/>
+                <a:cs typeface="Georgia"/>
+              </a:rPr>
+              <a:t>0.805</a:t>
+            </a:r>
+          </a:p>
+        </p:txBody>
+      </p:sp>
+      <p:sp>
+        <p:nvSpPr>
+          <p:cNvPr id="7" name="">
+            <a:extLst xmlns:a="http://schemas.openxmlformats.org/drawingml/2006/main">
+              <a:ext uri="{FF2B5EF4-FFF2-40B4-BE49-F238E27FC236}">
+                <a16:creationId xmlns:a16="http://schemas.microsoft.com/office/drawing/2014/main" id="{DEC4191C-8B95-4A79-A402-E4C88375E6C9}"/>
+              </a:ext>
+            </a:extLst>
+          </p:cNvPr>
+          <p:cNvSpPr>
+            <a:spLocks xmlns:a="http://schemas.openxmlformats.org/drawingml/2006/main" noGrp="1"/>
+          </p:cNvSpPr>
+          <p:nvPr/>
+        </p:nvSpPr>
+        <p:spPr>
+          <a:xfrm xmlns:a="http://schemas.openxmlformats.org/drawingml/2006/main">
+            <a:off x="638175" y="4429125"/>
+            <a:ext cx="3181350" cy="381000"/>
+          </a:xfrm>
+          <a:prstGeom xmlns:a="http://schemas.openxmlformats.org/drawingml/2006/main" prst="rect">
+            <a:avLst/>
+          </a:prstGeom>
+          <a:noFill xmlns:a="http://schemas.openxmlformats.org/drawingml/2006/main"/>
+          <a:ln xmlns:a="http://schemas.openxmlformats.org/drawingml/2006/main" w="0">
+            <a:noFill/>
+          </a:ln>
+        </p:spPr>
+        <p:txBody>
+          <a:bodyPr xmlns:a="http://schemas.openxmlformats.org/drawingml/2006/main">
+            <a:noAutofit/>
+          </a:bodyPr>
+          <a:lstStyle xmlns:a="http://schemas.openxmlformats.org/drawingml/2006/main"/>
+          <a:p xmlns:a="http://schemas.openxmlformats.org/drawingml/2006/main">
+            <a:pPr>
+              <a:defRPr sz="1950" b="0">
+                <a:solidFill>
+                  <a:srgbClr val="1A1F1C"/>
+                </a:solidFill>
+                <a:latin typeface="Helvetica Neue"/>
+                <a:ea typeface="Helvetica Neue"/>
+                <a:cs typeface="Helvetica Neue"/>
+              </a:defRPr>
+            </a:pPr>
+            <a:r>
+              <a:rPr sz="1950" b="0">
+                <a:solidFill>
+                  <a:srgbClr val="1A1F1C"/>
+                </a:solidFill>
+                <a:latin typeface="Helvetica Neue"/>
+                <a:ea typeface="Helvetica Neue"/>
+                <a:cs typeface="Helvetica Neue"/>
+              </a:rPr>
+              <a:t>Pooled ROC AUC</a:t>
+            </a:r>
+          </a:p>
+        </p:txBody>
+      </p:sp>
+      <p:sp>
+        <p:nvSpPr>
+          <p:cNvPr id="8" name="">
+            <a:extLst xmlns:a="http://schemas.openxmlformats.org/drawingml/2006/main">
+              <a:ext uri="{FF2B5EF4-FFF2-40B4-BE49-F238E27FC236}">
+                <a16:creationId xmlns:a16="http://schemas.microsoft.com/office/drawing/2014/main" id="{C0F8DEA8-E49C-4FE9-8EE2-66F5E17BFEAA}"/>
+              </a:ext>
+            </a:extLst>
+          </p:cNvPr>
+          <p:cNvSpPr>
+            <a:spLocks xmlns:a="http://schemas.openxmlformats.org/drawingml/2006/main" noGrp="1"/>
+          </p:cNvSpPr>
+          <p:nvPr/>
+        </p:nvSpPr>
+        <p:spPr>
+          <a:xfrm xmlns:a="http://schemas.openxmlformats.org/drawingml/2006/main">
+            <a:off x="638175" y="4876800"/>
+            <a:ext cx="3257550" cy="361950"/>
+          </a:xfrm>
+          <a:prstGeom xmlns:a="http://schemas.openxmlformats.org/drawingml/2006/main" prst="rect">
+            <a:avLst/>
+          </a:prstGeom>
+          <a:noFill xmlns:a="http://schemas.openxmlformats.org/drawingml/2006/main"/>
+          <a:ln xmlns:a="http://schemas.openxmlformats.org/drawingml/2006/main" w="0">
+            <a:noFill/>
+          </a:ln>
+        </p:spPr>
+        <p:txBody>
+          <a:bodyPr xmlns:a="http://schemas.openxmlformats.org/drawingml/2006/main">
+            <a:noAutofit/>
+          </a:bodyPr>
+          <a:lstStyle xmlns:a="http://schemas.openxmlformats.org/drawingml/2006/main"/>
+          <a:p xmlns:a="http://schemas.openxmlformats.org/drawingml/2006/main">
+            <a:pPr>
+              <a:defRPr sz="1650" b="0">
+                <a:solidFill>
+                  <a:srgbClr val="637267"/>
+                </a:solidFill>
+                <a:latin typeface="Helvetica Neue"/>
+                <a:ea typeface="Helvetica Neue"/>
+                <a:cs typeface="Helvetica Neue"/>
+              </a:defRPr>
+            </a:pPr>
+            <a:r>
+              <a:rPr sz="1650" b="0">
+                <a:solidFill>
+                  <a:srgbClr val="637267"/>
+                </a:solidFill>
+                <a:latin typeface="Helvetica Neue"/>
+                <a:ea typeface="Helvetica Neue"/>
+                <a:cs typeface="Helvetica Neue"/>
+              </a:rPr>
+              <a:t>95% interval  0.777 to 0.833</a:t>
+            </a:r>
+          </a:p>
+        </p:txBody>
+      </p:sp>
+      <p:sp>
+        <p:nvSpPr>
+          <p:cNvPr id="9" name="">
+            <a:extLst xmlns:a="http://schemas.openxmlformats.org/drawingml/2006/main">
+              <a:ext uri="{FF2B5EF4-FFF2-40B4-BE49-F238E27FC236}">
+                <a16:creationId xmlns:a16="http://schemas.microsoft.com/office/drawing/2014/main" id="{B549BD61-0A1B-45A4-A3CC-EE6F0A9F8B81}"/>
+              </a:ext>
+            </a:extLst>
+          </p:cNvPr>
+          <p:cNvSpPr>
+            <a:spLocks xmlns:a="http://schemas.openxmlformats.org/drawingml/2006/main" noGrp="1"/>
+          </p:cNvSpPr>
+          <p:nvPr/>
+        </p:nvSpPr>
+        <p:spPr>
+          <a:xfrm xmlns:a="http://schemas.openxmlformats.org/drawingml/2006/main">
+            <a:off x="638175" y="5429250"/>
+            <a:ext cx="3238500" cy="619125"/>
+          </a:xfrm>
+          <a:prstGeom xmlns:a="http://schemas.openxmlformats.org/drawingml/2006/main" prst="rect">
+            <a:avLst/>
+          </a:prstGeom>
+          <a:noFill xmlns:a="http://schemas.openxmlformats.org/drawingml/2006/main"/>
+          <a:ln xmlns:a="http://schemas.openxmlformats.org/drawingml/2006/main" w="0">
+            <a:noFill/>
+          </a:ln>
+        </p:spPr>
+        <p:txBody>
+          <a:bodyPr xmlns:a="http://schemas.openxmlformats.org/drawingml/2006/main">
+            <a:noAutofit/>
+          </a:bodyPr>
+          <a:lstStyle xmlns:a="http://schemas.openxmlformats.org/drawingml/2006/main"/>
+          <a:p xmlns:a="http://schemas.openxmlformats.org/drawingml/2006/main">
+            <a:pPr>
+              <a:defRPr sz="1575" b="0">
+                <a:solidFill>
+                  <a:srgbClr val="637267"/>
+                </a:solidFill>
+                <a:latin typeface="Helvetica Neue"/>
+                <a:ea typeface="Helvetica Neue"/>
+                <a:cs typeface="Helvetica Neue"/>
+              </a:defRPr>
+            </a:pPr>
+            <a:r>
+              <a:rPr sz="1575" b="0">
+                <a:solidFill>
+                  <a:srgbClr val="637267"/>
+                </a:solidFill>
+                <a:latin typeface="Helvetica Neue"/>
+                <a:ea typeface="Helvetica Neue"/>
+                <a:cs typeface="Helvetica Neue"/>
+              </a:rPr>
+              <a:t>200 bootstrap samples</a:t>
+            </a:r>
+          </a:p>
+          <a:p xmlns:a="http://schemas.openxmlformats.org/drawingml/2006/main">
+            <a:pPr>
+              <a:defRPr sz="1575" b="0">
+                <a:solidFill>
+                  <a:srgbClr val="637267"/>
+                </a:solidFill>
+                <a:latin typeface="Helvetica Neue"/>
+                <a:ea typeface="Helvetica Neue"/>
+                <a:cs typeface="Helvetica Neue"/>
+              </a:defRPr>
+            </a:pPr>
+            <a:r>
+              <a:rPr sz="1575" b="0">
+                <a:solidFill>
+                  <a:srgbClr val="637267"/>
+                </a:solidFill>
+                <a:latin typeface="Helvetica Neue"/>
+                <a:ea typeface="Helvetica Neue"/>
+                <a:cs typeface="Helvetica Neue"/>
+              </a:rPr>
+              <a:t>clustered by player</a:t>
+            </a:r>
+          </a:p>
+        </p:txBody>
+      </p:sp>
+      <p:graphicFrame>
+        <p:nvGraphicFramePr>
+          <p:cNvPr id="22" name="Chart"/>
+          <p:cNvGraphicFramePr/>
+          <p:nvPr/>
+        </p:nvGraphicFramePr>
+        <p:xfrm>
+          <a:off xmlns:a="http://schemas.openxmlformats.org/drawingml/2006/main" x="4276725" y="2619375"/>
+          <a:ext xmlns:a="http://schemas.openxmlformats.org/drawingml/2006/main" cx="7391400" cy="3162300"/>
+        </p:xfrm>
+        <a:graphic xmlns:a="http://schemas.openxmlformats.org/drawingml/2006/main">
+          <a:graphicData uri="http://schemas.openxmlformats.org/drawingml/2006/chart">
+            <c:chart xmlns:r="http://schemas.openxmlformats.org/officeDocument/2006/relationships" xmlns:c="http://schemas.openxmlformats.org/drawingml/2006/chart" r:id="R6f275eaf8e2545a7"/>
+          </a:graphicData>
+        </a:graphic>
+      </p:graphicFrame>
+      <p:sp>
+        <p:nvSpPr>
+          <p:cNvPr id="11" name="">
+            <a:extLst xmlns:a="http://schemas.openxmlformats.org/drawingml/2006/main">
+              <a:ext uri="{FF2B5EF4-FFF2-40B4-BE49-F238E27FC236}">
+                <a16:creationId xmlns:a16="http://schemas.microsoft.com/office/drawing/2014/main" id="{01E32625-0510-46BD-B177-30D1DF0407ED}"/>
+              </a:ext>
+            </a:extLst>
+          </p:cNvPr>
+          <p:cNvSpPr>
+            <a:spLocks xmlns:a="http://schemas.openxmlformats.org/drawingml/2006/main" noGrp="1"/>
+          </p:cNvSpPr>
+          <p:nvPr/>
+        </p:nvSpPr>
+        <p:spPr>
+          <a:xfrm xmlns:a="http://schemas.openxmlformats.org/drawingml/2006/main">
+            <a:off x="4524375" y="2447925"/>
+            <a:ext cx="1524000" cy="266700"/>
           </a:xfrm>
           <a:prstGeom xmlns:a="http://schemas.openxmlformats.org/drawingml/2006/main" prst="rect">
             <a:avLst/>
@@ -1666,7 +2269,7 @@
             <a:pPr>
               <a:defRPr sz="1275" b="0">
                 <a:solidFill>
-                  <a:srgbClr val="617266"/>
+                  <a:srgbClr val="637267"/>
                 </a:solidFill>
                 <a:latin typeface="Helvetica Neue"/>
                 <a:ea typeface="Helvetica Neue"/>
@@ -1676,39 +2279,23 @@
             <a:r>
               <a:rPr sz="1275" b="0">
                 <a:solidFill>
-                  <a:srgbClr val="617266"/>
+                  <a:srgbClr val="637267"/>
                 </a:solidFill>
                 <a:latin typeface="Helvetica Neue"/>
                 <a:ea typeface="Helvetica Neue"/>
                 <a:cs typeface="Helvetica Neue"/>
               </a:rPr>
-              <a:t>1/2</a:t>
+              <a:t>ROC AUC</a:t>
             </a:r>
           </a:p>
         </p:txBody>
       </p:sp>
-      <p:graphicFrame>
-        <p:nvGraphicFramePr>
-          <p:cNvPr id="14" name="Chart"/>
-          <p:cNvGraphicFramePr/>
-          <p:nvPr/>
-        </p:nvGraphicFramePr>
-        <p:xfrm>
-          <a:off xmlns:a="http://schemas.openxmlformats.org/drawingml/2006/main" x="590550" y="1809750"/>
-          <a:ext xmlns:a="http://schemas.openxmlformats.org/drawingml/2006/main" cx="7334250" cy="3810000"/>
-        </p:xfrm>
-        <a:graphic xmlns:a="http://schemas.openxmlformats.org/drawingml/2006/main">
-          <a:graphicData uri="http://schemas.openxmlformats.org/drawingml/2006/chart">
-            <c:chart xmlns:r="http://schemas.openxmlformats.org/officeDocument/2006/relationships" xmlns:c="http://schemas.openxmlformats.org/drawingml/2006/chart" r:id="R57f391015fcc4a33"/>
-          </a:graphicData>
-        </a:graphic>
-      </p:graphicFrame>
       <p:sp>
         <p:nvSpPr>
-          <p:cNvPr id="5" name="">
+          <p:cNvPr id="12" name="">
             <a:extLst xmlns:a="http://schemas.openxmlformats.org/drawingml/2006/main">
               <a:ext uri="{FF2B5EF4-FFF2-40B4-BE49-F238E27FC236}">
-                <a16:creationId xmlns:a16="http://schemas.microsoft.com/office/drawing/2014/main" id="{780F140B-940F-4FBF-931E-1FA11DEBFE1F}"/>
+                <a16:creationId xmlns:a16="http://schemas.microsoft.com/office/drawing/2014/main" id="{BEB1FB34-5600-4A8C-A17C-9380AC27484C}"/>
               </a:ext>
             </a:extLst>
           </p:cNvPr>
@@ -1719,8 +2306,8 @@
         </p:nvSpPr>
         <p:spPr>
           <a:xfrm xmlns:a="http://schemas.openxmlformats.org/drawingml/2006/main">
-            <a:off x="8572500" y="1828800"/>
-            <a:ext cx="2857500" cy="590550"/>
+            <a:off x="619125" y="6296025"/>
+            <a:ext cx="10858500" cy="295275"/>
           </a:xfrm>
           <a:prstGeom xmlns:a="http://schemas.openxmlformats.org/drawingml/2006/main" prst="rect">
             <a:avLst/>
@@ -1737,9 +2324,9 @@
           <a:lstStyle xmlns:a="http://schemas.openxmlformats.org/drawingml/2006/main"/>
           <a:p xmlns:a="http://schemas.openxmlformats.org/drawingml/2006/main">
             <a:pPr>
-              <a:defRPr sz="3600" b="1">
-                <a:solidFill>
-                  <a:srgbClr val="203F30"/>
+              <a:defRPr sz="1425" b="0">
+                <a:solidFill>
+                  <a:srgbClr val="637267"/>
                 </a:solidFill>
                 <a:latin typeface="Helvetica Neue"/>
                 <a:ea typeface="Helvetica Neue"/>
@@ -1747,25 +2334,54 @@
               </a:defRPr>
             </a:pPr>
             <a:r>
-              <a:rPr sz="3600" b="1">
-                <a:solidFill>
-                  <a:srgbClr val="203F30"/>
+              <a:rPr sz="1425" b="0">
+                <a:solidFill>
+                  <a:srgbClr val="637267"/>
                 </a:solidFill>
                 <a:latin typeface="Helvetica Neue"/>
                 <a:ea typeface="Helvetica Neue"/>
                 <a:cs typeface="Helvetica Neue"/>
               </a:rPr>
-              <a:t>2,057</a:t>
+              <a:t>Every dated valuation precedes July 1. Missing outcomes remain unknown.</a:t>
             </a:r>
           </a:p>
         </p:txBody>
       </p:sp>
+    </p:spTree>
+    <p:extLst>
+      <p:ext uri="{BB962C8B-B14F-4D97-AF65-F5344CB8AC3E}">
+        <p14:creationId xmlns:p14="http://schemas.microsoft.com/office/powerpoint/2010/main" val="777022552"/>
+      </p:ext>
+    </p:extLst>
+  </p:cSld>
+</p:sld>
+</file>
+
+<file path=ppt/slides/slide2.xml><?xml version="1.0" encoding="utf-8"?>
+<p:sld xmlns:p="http://schemas.openxmlformats.org/presentationml/2006/main">
+  <p:cSld>
+    <p:bg>
+      <p:bgPr>
+        <a:solidFill xmlns:a="http://schemas.openxmlformats.org/drawingml/2006/main">
+          <a:srgbClr val="173F31"/>
+        </a:solidFill>
+      </p:bgPr>
+    </p:bg>
+    <p:spTree>
+      <p:nvGrpSpPr>
+        <p:cNvPr id="1" name=""/>
+        <p:cNvGrpSpPr/>
+        <p:nvPr/>
+      </p:nvGrpSpPr>
+      <p:grpSpPr>
+        <a:xfrm xmlns:a="http://schemas.openxmlformats.org/drawingml/2006/main"/>
+      </p:grpSpPr>
       <p:sp>
         <p:nvSpPr>
-          <p:cNvPr id="6" name="">
+          <p:cNvPr id="12" name="">
             <a:extLst xmlns:a="http://schemas.openxmlformats.org/drawingml/2006/main">
               <a:ext uri="{FF2B5EF4-FFF2-40B4-BE49-F238E27FC236}">
-                <a16:creationId xmlns:a16="http://schemas.microsoft.com/office/drawing/2014/main" id="{63DB00E5-E3AF-40D8-9194-B84EB5BCA0E8}"/>
+                <a16:creationId xmlns:a16="http://schemas.microsoft.com/office/drawing/2014/main" id="{D6699856-500D-4103-BE3D-8AE65A3D9853}"/>
               </a:ext>
             </a:extLst>
           </p:cNvPr>
@@ -1776,8 +2392,8 @@
         </p:nvSpPr>
         <p:spPr>
           <a:xfrm xmlns:a="http://schemas.openxmlformats.org/drawingml/2006/main">
-            <a:off x="8572500" y="2400300"/>
-            <a:ext cx="2857500" cy="342900"/>
+            <a:off x="609600" y="352425"/>
+            <a:ext cx="9525000" cy="285750"/>
           </a:xfrm>
           <a:prstGeom xmlns:a="http://schemas.openxmlformats.org/drawingml/2006/main" prst="rect">
             <a:avLst/>
@@ -1794,9 +2410,9 @@
           <a:lstStyle xmlns:a="http://schemas.openxmlformats.org/drawingml/2006/main"/>
           <a:p xmlns:a="http://schemas.openxmlformats.org/drawingml/2006/main">
             <a:pPr>
-              <a:defRPr sz="1800" b="0">
-                <a:solidFill>
-                  <a:srgbClr val="617266"/>
+              <a:defRPr sz="1200" b="1">
+                <a:solidFill>
+                  <a:srgbClr val="B3C6B8"/>
                 </a:solidFill>
                 <a:latin typeface="Helvetica Neue"/>
                 <a:ea typeface="Helvetica Neue"/>
@@ -1804,25 +2420,25 @@
               </a:defRPr>
             </a:pPr>
             <a:r>
-              <a:rPr sz="1800" b="0">
-                <a:solidFill>
-                  <a:srgbClr val="617266"/>
+              <a:rPr sz="1200" b="1">
+                <a:solidFill>
+                  <a:srgbClr val="B3C6B8"/>
                 </a:solidFill>
                 <a:latin typeface="Helvetica Neue"/>
                 <a:ea typeface="Helvetica Neue"/>
                 <a:cs typeface="Helvetica Neue"/>
               </a:rPr>
-              <a:t>test observations</a:t>
+              <a:t>FOOTBALL RECRUITMENT</a:t>
             </a:r>
           </a:p>
         </p:txBody>
       </p:sp>
       <p:sp>
         <p:nvSpPr>
-          <p:cNvPr id="7" name="">
+          <p:cNvPr id="2" name="">
             <a:extLst xmlns:a="http://schemas.openxmlformats.org/drawingml/2006/main">
               <a:ext uri="{FF2B5EF4-FFF2-40B4-BE49-F238E27FC236}">
-                <a16:creationId xmlns:a16="http://schemas.microsoft.com/office/drawing/2014/main" id="{ACDCE035-E40A-4234-86B5-FAF043A9446C}"/>
+                <a16:creationId xmlns:a16="http://schemas.microsoft.com/office/drawing/2014/main" id="{32984A56-4E55-46FC-8D28-FA98CC30BB28}"/>
               </a:ext>
             </a:extLst>
           </p:cNvPr>
@@ -1833,8 +2449,8 @@
         </p:nvSpPr>
         <p:spPr>
           <a:xfrm xmlns:a="http://schemas.openxmlformats.org/drawingml/2006/main">
-            <a:off x="8572500" y="3238500"/>
-            <a:ext cx="2857500" cy="590550"/>
+            <a:off x="11049000" y="314325"/>
+            <a:ext cx="666750" cy="400050"/>
           </a:xfrm>
           <a:prstGeom xmlns:a="http://schemas.openxmlformats.org/drawingml/2006/main" prst="rect">
             <a:avLst/>
@@ -1851,35 +2467,35 @@
           <a:lstStyle xmlns:a="http://schemas.openxmlformats.org/drawingml/2006/main"/>
           <a:p xmlns:a="http://schemas.openxmlformats.org/drawingml/2006/main">
             <a:pPr>
-              <a:defRPr sz="3600" b="1">
-                <a:solidFill>
-                  <a:srgbClr val="203F30"/>
-                </a:solidFill>
-                <a:latin typeface="Helvetica Neue"/>
-                <a:ea typeface="Helvetica Neue"/>
-                <a:cs typeface="Helvetica Neue"/>
+              <a:defRPr sz="2100" b="0">
+                <a:solidFill>
+                  <a:srgbClr val="F7F5F0"/>
+                </a:solidFill>
+                <a:latin typeface="Georgia"/>
+                <a:ea typeface="Georgia"/>
+                <a:cs typeface="Georgia"/>
               </a:defRPr>
             </a:pPr>
             <a:r>
-              <a:rPr sz="3600" b="1">
-                <a:solidFill>
-                  <a:srgbClr val="203F30"/>
-                </a:solidFill>
-                <a:latin typeface="Helvetica Neue"/>
-                <a:ea typeface="Helvetica Neue"/>
-                <a:cs typeface="Helvetica Neue"/>
+              <a:rPr sz="2100" b="0">
+                <a:solidFill>
+                  <a:srgbClr val="F7F5F0"/>
+                </a:solidFill>
+                <a:latin typeface="Georgia"/>
+                <a:ea typeface="Georgia"/>
+                <a:cs typeface="Georgia"/>
               </a:rPr>
-              <a:t>0.805</a:t>
+              <a:t>02</a:t>
             </a:r>
           </a:p>
         </p:txBody>
       </p:sp>
       <p:sp>
         <p:nvSpPr>
-          <p:cNvPr id="8" name="">
+          <p:cNvPr id="3" name="">
             <a:extLst xmlns:a="http://schemas.openxmlformats.org/drawingml/2006/main">
               <a:ext uri="{FF2B5EF4-FFF2-40B4-BE49-F238E27FC236}">
-                <a16:creationId xmlns:a16="http://schemas.microsoft.com/office/drawing/2014/main" id="{3A6DF01D-08E2-4ADF-AEF8-00AC2B0B5640}"/>
+                <a16:creationId xmlns:a16="http://schemas.microsoft.com/office/drawing/2014/main" id="{2B78E093-219A-45C3-B27C-9350D07A59A0}"/>
               </a:ext>
             </a:extLst>
           </p:cNvPr>
@@ -1890,8 +2506,8 @@
         </p:nvSpPr>
         <p:spPr>
           <a:xfrm xmlns:a="http://schemas.openxmlformats.org/drawingml/2006/main">
-            <a:off x="8572500" y="3829050"/>
-            <a:ext cx="2857500" cy="361950"/>
+            <a:off x="571500" y="1066800"/>
+            <a:ext cx="4514850" cy="1581150"/>
           </a:xfrm>
           <a:prstGeom xmlns:a="http://schemas.openxmlformats.org/drawingml/2006/main" prst="rect">
             <a:avLst/>
@@ -1908,35 +2524,58 @@
           <a:lstStyle xmlns:a="http://schemas.openxmlformats.org/drawingml/2006/main"/>
           <a:p xmlns:a="http://schemas.openxmlformats.org/drawingml/2006/main">
             <a:pPr>
-              <a:defRPr sz="1800" b="0">
-                <a:solidFill>
-                  <a:srgbClr val="617266"/>
-                </a:solidFill>
-                <a:latin typeface="Helvetica Neue"/>
-                <a:ea typeface="Helvetica Neue"/>
-                <a:cs typeface="Helvetica Neue"/>
+              <a:defRPr sz="4575" b="0">
+                <a:solidFill>
+                  <a:srgbClr val="F7F5F0"/>
+                </a:solidFill>
+                <a:latin typeface="Georgia"/>
+                <a:ea typeface="Georgia"/>
+                <a:cs typeface="Georgia"/>
               </a:defRPr>
             </a:pPr>
             <a:r>
-              <a:rPr sz="1800" b="0">
-                <a:solidFill>
-                  <a:srgbClr val="617266"/>
-                </a:solidFill>
-                <a:latin typeface="Helvetica Neue"/>
-                <a:ea typeface="Helvetica Neue"/>
-                <a:cs typeface="Helvetica Neue"/>
+              <a:rPr sz="4575" b="0">
+                <a:solidFill>
+                  <a:srgbClr val="F7F5F0"/>
+                </a:solidFill>
+                <a:latin typeface="Georgia"/>
+                <a:ea typeface="Georgia"/>
+                <a:cs typeface="Georgia"/>
               </a:rPr>
-              <a:t>Logistic pooled AUC</a:t>
+              <a:t>Small changes,</a:t>
+            </a:r>
+          </a:p>
+          <a:p xmlns:a="http://schemas.openxmlformats.org/drawingml/2006/main">
+            <a:pPr>
+              <a:defRPr sz="4575" b="0">
+                <a:solidFill>
+                  <a:srgbClr val="F7F5F0"/>
+                </a:solidFill>
+                <a:latin typeface="Georgia"/>
+                <a:ea typeface="Georgia"/>
+                <a:cs typeface="Georgia"/>
+              </a:defRPr>
+            </a:pPr>
+            <a:r>
+              <a:rPr sz="4575" b="0">
+                <a:solidFill>
+                  <a:srgbClr val="F7F5F0"/>
+                </a:solidFill>
+                <a:latin typeface="Georgia"/>
+                <a:ea typeface="Georgia"/>
+                <a:cs typeface="Georgia"/>
+              </a:rPr>
+              <a:t>stable scores</a:t>
             </a:r>
           </a:p>
         </p:txBody>
       </p:sp>
       <p:sp>
         <p:nvSpPr>
-          <p:cNvPr id="9" name="">
+          <p:cNvPr id="4" name="">
             <a:extLst xmlns:a="http://schemas.openxmlformats.org/drawingml/2006/main">
               <a:ext uri="{FF2B5EF4-FFF2-40B4-BE49-F238E27FC236}">
-                <a16:creationId xmlns:a16="http://schemas.microsoft.com/office/drawing/2014/main" id="{24226C65-37E5-4145-81E3-033EE7F22CDB}"/>
+                <a16:creationId xmlns:a16="http://schemas.microsoft.com/office/drawing/2014/main" id="{2259057E-9D0F-430E-84BE-4D7EE66B5A94}"/>
               </a:ext>
             </a:extLst>
           </p:cNvPr>
@@ -1947,8 +2586,202 @@
         </p:nvSpPr>
         <p:spPr>
           <a:xfrm xmlns:a="http://schemas.openxmlformats.org/drawingml/2006/main">
-            <a:off x="8572500" y="4533900"/>
-            <a:ext cx="2857500" cy="723900"/>
+            <a:off x="619125" y="2905125"/>
+            <a:ext cx="4143375" cy="695325"/>
+          </a:xfrm>
+          <a:prstGeom xmlns:a="http://schemas.openxmlformats.org/drawingml/2006/main" prst="rect">
+            <a:avLst/>
+          </a:prstGeom>
+          <a:noFill xmlns:a="http://schemas.openxmlformats.org/drawingml/2006/main"/>
+          <a:ln xmlns:a="http://schemas.openxmlformats.org/drawingml/2006/main" w="0">
+            <a:noFill/>
+          </a:ln>
+        </p:spPr>
+        <p:txBody>
+          <a:bodyPr xmlns:a="http://schemas.openxmlformats.org/drawingml/2006/main">
+            <a:noAutofit/>
+          </a:bodyPr>
+          <a:lstStyle xmlns:a="http://schemas.openxmlformats.org/drawingml/2006/main"/>
+          <a:p xmlns:a="http://schemas.openxmlformats.org/drawingml/2006/main">
+            <a:pPr>
+              <a:defRPr sz="1950" b="0">
+                <a:solidFill>
+                  <a:srgbClr val="C0D2C4"/>
+                </a:solidFill>
+                <a:latin typeface="Helvetica Neue"/>
+                <a:ea typeface="Helvetica Neue"/>
+                <a:cs typeface="Helvetica Neue"/>
+              </a:defRPr>
+            </a:pPr>
+            <a:r>
+              <a:rPr sz="1950" b="0">
+                <a:solidFill>
+                  <a:srgbClr val="C0D2C4"/>
+                </a:solidFill>
+                <a:latin typeface="Helvetica Neue"/>
+                <a:ea typeface="Helvetica Neue"/>
+                <a:cs typeface="Helvetica Neue"/>
+              </a:rPr>
+              <a:t>Logistic regression under</a:t>
+            </a:r>
+          </a:p>
+          <a:p xmlns:a="http://schemas.openxmlformats.org/drawingml/2006/main">
+            <a:pPr>
+              <a:defRPr sz="1950" b="0">
+                <a:solidFill>
+                  <a:srgbClr val="C0D2C4"/>
+                </a:solidFill>
+                <a:latin typeface="Helvetica Neue"/>
+                <a:ea typeface="Helvetica Neue"/>
+                <a:cs typeface="Helvetica Neue"/>
+              </a:defRPr>
+            </a:pPr>
+            <a:r>
+              <a:rPr sz="1950" b="0">
+                <a:solidFill>
+                  <a:srgbClr val="C0D2C4"/>
+                </a:solidFill>
+                <a:latin typeface="Helvetica Neue"/>
+                <a:ea typeface="Helvetica Neue"/>
+                <a:cs typeface="Helvetica Neue"/>
+              </a:rPr>
+              <a:t>1% measurement noise</a:t>
+            </a:r>
+          </a:p>
+        </p:txBody>
+      </p:sp>
+      <p:sp>
+        <p:nvSpPr>
+          <p:cNvPr id="5" name="">
+            <a:extLst xmlns:a="http://schemas.openxmlformats.org/drawingml/2006/main">
+              <a:ext uri="{FF2B5EF4-FFF2-40B4-BE49-F238E27FC236}">
+                <a16:creationId xmlns:a16="http://schemas.microsoft.com/office/drawing/2014/main" id="{3524E159-4A06-45DA-A7A8-B6300CD1F860}"/>
+              </a:ext>
+            </a:extLst>
+          </p:cNvPr>
+          <p:cNvSpPr>
+            <a:spLocks xmlns:a="http://schemas.openxmlformats.org/drawingml/2006/main" noGrp="1"/>
+          </p:cNvSpPr>
+          <p:nvPr/>
+        </p:nvSpPr>
+        <p:spPr>
+          <a:xfrm xmlns:a="http://schemas.openxmlformats.org/drawingml/2006/main">
+            <a:off x="561975" y="3829050"/>
+            <a:ext cx="2952750" cy="1133475"/>
+          </a:xfrm>
+          <a:prstGeom xmlns:a="http://schemas.openxmlformats.org/drawingml/2006/main" prst="rect">
+            <a:avLst/>
+          </a:prstGeom>
+          <a:noFill xmlns:a="http://schemas.openxmlformats.org/drawingml/2006/main"/>
+          <a:ln xmlns:a="http://schemas.openxmlformats.org/drawingml/2006/main" w="0">
+            <a:noFill/>
+          </a:ln>
+        </p:spPr>
+        <p:txBody>
+          <a:bodyPr xmlns:a="http://schemas.openxmlformats.org/drawingml/2006/main">
+            <a:noAutofit/>
+          </a:bodyPr>
+          <a:lstStyle xmlns:a="http://schemas.openxmlformats.org/drawingml/2006/main"/>
+          <a:p xmlns:a="http://schemas.openxmlformats.org/drawingml/2006/main">
+            <a:pPr>
+              <a:defRPr sz="7200" b="0">
+                <a:solidFill>
+                  <a:srgbClr val="F7F5F0"/>
+                </a:solidFill>
+                <a:latin typeface="Georgia"/>
+                <a:ea typeface="Georgia"/>
+                <a:cs typeface="Georgia"/>
+              </a:defRPr>
+            </a:pPr>
+            <a:r>
+              <a:rPr sz="7200" b="0">
+                <a:solidFill>
+                  <a:srgbClr val="F7F5F0"/>
+                </a:solidFill>
+                <a:latin typeface="Georgia"/>
+                <a:ea typeface="Georgia"/>
+                <a:cs typeface="Georgia"/>
+              </a:rPr>
+              <a:t>0.10</a:t>
+            </a:r>
+          </a:p>
+        </p:txBody>
+      </p:sp>
+      <p:sp>
+        <p:nvSpPr>
+          <p:cNvPr id="6" name="">
+            <a:extLst xmlns:a="http://schemas.openxmlformats.org/drawingml/2006/main">
+              <a:ext uri="{FF2B5EF4-FFF2-40B4-BE49-F238E27FC236}">
+                <a16:creationId xmlns:a16="http://schemas.microsoft.com/office/drawing/2014/main" id="{9EEF994A-572D-4DCD-BD1D-827FD229DDF1}"/>
+              </a:ext>
+            </a:extLst>
+          </p:cNvPr>
+          <p:cNvSpPr>
+            <a:spLocks xmlns:a="http://schemas.openxmlformats.org/drawingml/2006/main" noGrp="1"/>
+          </p:cNvSpPr>
+          <p:nvPr/>
+        </p:nvSpPr>
+        <p:spPr>
+          <a:xfrm xmlns:a="http://schemas.openxmlformats.org/drawingml/2006/main">
+            <a:off x="3143250" y="4305300"/>
+            <a:ext cx="904875" cy="476250"/>
+          </a:xfrm>
+          <a:prstGeom xmlns:a="http://schemas.openxmlformats.org/drawingml/2006/main" prst="rect">
+            <a:avLst/>
+          </a:prstGeom>
+          <a:noFill xmlns:a="http://schemas.openxmlformats.org/drawingml/2006/main"/>
+          <a:ln xmlns:a="http://schemas.openxmlformats.org/drawingml/2006/main" w="0">
+            <a:noFill/>
+          </a:ln>
+        </p:spPr>
+        <p:txBody>
+          <a:bodyPr xmlns:a="http://schemas.openxmlformats.org/drawingml/2006/main">
+            <a:noAutofit/>
+          </a:bodyPr>
+          <a:lstStyle xmlns:a="http://schemas.openxmlformats.org/drawingml/2006/main"/>
+          <a:p xmlns:a="http://schemas.openxmlformats.org/drawingml/2006/main">
+            <a:pPr>
+              <a:defRPr sz="2625" b="0">
+                <a:solidFill>
+                  <a:srgbClr val="C0D2C4"/>
+                </a:solidFill>
+                <a:latin typeface="Georgia"/>
+                <a:ea typeface="Georgia"/>
+                <a:cs typeface="Georgia"/>
+              </a:defRPr>
+            </a:pPr>
+            <a:r>
+              <a:rPr sz="2625" b="0">
+                <a:solidFill>
+                  <a:srgbClr val="C0D2C4"/>
+                </a:solidFill>
+                <a:latin typeface="Georgia"/>
+                <a:ea typeface="Georgia"/>
+                <a:cs typeface="Georgia"/>
+              </a:rPr>
+              <a:t>pp</a:t>
+            </a:r>
+          </a:p>
+        </p:txBody>
+      </p:sp>
+      <p:sp>
+        <p:nvSpPr>
+          <p:cNvPr id="7" name="">
+            <a:extLst xmlns:a="http://schemas.openxmlformats.org/drawingml/2006/main">
+              <a:ext uri="{FF2B5EF4-FFF2-40B4-BE49-F238E27FC236}">
+                <a16:creationId xmlns:a16="http://schemas.microsoft.com/office/drawing/2014/main" id="{D6E6F951-A4FD-4640-A538-EAEDC5D6E223}"/>
+              </a:ext>
+            </a:extLst>
+          </p:cNvPr>
+          <p:cNvSpPr>
+            <a:spLocks xmlns:a="http://schemas.openxmlformats.org/drawingml/2006/main" noGrp="1"/>
+          </p:cNvSpPr>
+          <p:nvPr/>
+        </p:nvSpPr>
+        <p:spPr>
+          <a:xfrm xmlns:a="http://schemas.openxmlformats.org/drawingml/2006/main">
+            <a:off x="619125" y="5114925"/>
+            <a:ext cx="4114800" cy="361950"/>
           </a:xfrm>
           <a:prstGeom xmlns:a="http://schemas.openxmlformats.org/drawingml/2006/main" prst="rect">
             <a:avLst/>
@@ -1967,7 +2800,7 @@
             <a:pPr>
               <a:defRPr sz="1650" b="0">
                 <a:solidFill>
-                  <a:srgbClr val="203F30"/>
+                  <a:srgbClr val="C0D2C4"/>
                 </a:solidFill>
                 <a:latin typeface="Helvetica Neue"/>
                 <a:ea typeface="Helvetica Neue"/>
@@ -1977,46 +2810,23 @@
             <a:r>
               <a:rPr sz="1650" b="0">
                 <a:solidFill>
-                  <a:srgbClr val="203F30"/>
+                  <a:srgbClr val="C0D2C4"/>
                 </a:solidFill>
                 <a:latin typeface="Helvetica Neue"/>
                 <a:ea typeface="Helvetica Neue"/>
                 <a:cs typeface="Helvetica Neue"/>
               </a:rPr>
-              <a:t>200 player-cluster samples</a:t>
-            </a:r>
-          </a:p>
-          <a:p xmlns:a="http://schemas.openxmlformats.org/drawingml/2006/main">
-            <a:pPr>
-              <a:defRPr sz="1650" b="0">
-                <a:solidFill>
-                  <a:srgbClr val="203F30"/>
-                </a:solidFill>
-                <a:latin typeface="Helvetica Neue"/>
-                <a:ea typeface="Helvetica Neue"/>
-                <a:cs typeface="Helvetica Neue"/>
-              </a:defRPr>
-            </a:pPr>
-            <a:r>
-              <a:rPr sz="1650" b="0">
-                <a:solidFill>
-                  <a:srgbClr val="203F30"/>
-                </a:solidFill>
-                <a:latin typeface="Helvetica Neue"/>
-                <a:ea typeface="Helvetica Neue"/>
-                <a:cs typeface="Helvetica Neue"/>
-              </a:rPr>
-              <a:t>95% CI 0.777 to 0.833</a:t>
+              <a:t>Mean absolute score change</a:t>
             </a:r>
           </a:p>
         </p:txBody>
       </p:sp>
       <p:sp>
         <p:nvSpPr>
-          <p:cNvPr id="10" name="">
+          <p:cNvPr id="8" name="">
             <a:extLst xmlns:a="http://schemas.openxmlformats.org/drawingml/2006/main">
               <a:ext uri="{FF2B5EF4-FFF2-40B4-BE49-F238E27FC236}">
-                <a16:creationId xmlns:a16="http://schemas.microsoft.com/office/drawing/2014/main" id="{72A76D15-121C-4AEF-BDD7-332B76492A1F}"/>
+                <a16:creationId xmlns:a16="http://schemas.microsoft.com/office/drawing/2014/main" id="{1E4FC2E4-B53A-47FE-89AB-7A21B67E4241}"/>
               </a:ext>
             </a:extLst>
           </p:cNvPr>
@@ -2027,8 +2837,8 @@
         </p:nvSpPr>
         <p:spPr>
           <a:xfrm xmlns:a="http://schemas.openxmlformats.org/drawingml/2006/main">
-            <a:off x="590550" y="5905500"/>
-            <a:ext cx="10287000" cy="514350"/>
+            <a:off x="5372100" y="1504950"/>
+            <a:ext cx="6124575" cy="342900"/>
           </a:xfrm>
           <a:prstGeom xmlns:a="http://schemas.openxmlformats.org/drawingml/2006/main" prst="rect">
             <a:avLst/>
@@ -2045,9 +2855,9 @@
           <a:lstStyle xmlns:a="http://schemas.openxmlformats.org/drawingml/2006/main"/>
           <a:p xmlns:a="http://schemas.openxmlformats.org/drawingml/2006/main">
             <a:pPr>
-              <a:defRPr sz="1650" b="0">
-                <a:solidFill>
-                  <a:srgbClr val="617266"/>
+              <a:defRPr sz="1725" b="0">
+                <a:solidFill>
+                  <a:srgbClr val="F7F5F0"/>
                 </a:solidFill>
                 <a:latin typeface="Helvetica Neue"/>
                 <a:ea typeface="Helvetica Neue"/>
@@ -2055,54 +2865,421 @@
               </a:defRPr>
             </a:pPr>
             <a:r>
-              <a:rPr sz="1650" b="0">
-                <a:solidFill>
-                  <a:srgbClr val="617266"/>
+              <a:rPr sz="1725" b="0">
+                <a:solidFill>
+                  <a:srgbClr val="F7F5F0"/>
                 </a:solidFill>
                 <a:latin typeface="Helvetica Neue"/>
                 <a:ea typeface="Helvetica Neue"/>
                 <a:cs typeface="Helvetica Neue"/>
               </a:rPr>
-              <a:t>Every dated valuation precedes July 1. Missing next-season outcomes remain unknown.</a:t>
+              <a:t>Mean score change, percentage points</a:t>
             </a:r>
           </a:p>
         </p:txBody>
       </p:sp>
-    </p:spTree>
-    <p:extLst>
-      <p:ext uri="{BB962C8B-B14F-4D97-AF65-F5344CB8AC3E}">
-        <p14:creationId xmlns:p14="http://schemas.microsoft.com/office/powerpoint/2010/main" val="1438899718"/>
-      </p:ext>
-    </p:extLst>
-  </p:cSld>
-</p:sld>
-</file>
-
-<file path=ppt/slides/slide2.xml><?xml version="1.0" encoding="utf-8"?>
-<p:sld xmlns:p="http://schemas.openxmlformats.org/presentationml/2006/main">
-  <p:cSld>
-    <p:bg>
-      <p:bgPr>
-        <a:solidFill xmlns:a="http://schemas.openxmlformats.org/drawingml/2006/main">
-          <a:srgbClr val="F7F6F0"/>
-        </a:solidFill>
-      </p:bgPr>
-    </p:bg>
-    <p:spTree>
-      <p:nvGrpSpPr>
-        <p:cNvPr id="1" name=""/>
-        <p:cNvGrpSpPr/>
-        <p:nvPr/>
-      </p:nvGrpSpPr>
-      <p:grpSpPr>
-        <a:xfrm xmlns:a="http://schemas.openxmlformats.org/drawingml/2006/main"/>
-      </p:grpSpPr>
+      <p:graphicFrame>
+        <p:nvGraphicFramePr>
+          <p:cNvPr id="20" name="Chart"/>
+          <p:cNvGraphicFramePr/>
+          <p:nvPr/>
+        </p:nvGraphicFramePr>
+        <p:xfrm>
+          <a:off xmlns:a="http://schemas.openxmlformats.org/drawingml/2006/main" x="4886325" y="2057400"/>
+          <a:ext xmlns:a="http://schemas.openxmlformats.org/drawingml/2006/main" cx="6715125" cy="2209800"/>
+        </p:xfrm>
+        <a:graphic xmlns:a="http://schemas.openxmlformats.org/drawingml/2006/main">
+          <a:graphicData uri="http://schemas.openxmlformats.org/drawingml/2006/chart">
+            <c:chart xmlns:r="http://schemas.openxmlformats.org/officeDocument/2006/relationships" xmlns:c="http://schemas.openxmlformats.org/drawingml/2006/chart" r:id="R057319638bbd4f0e"/>
+          </a:graphicData>
+        </a:graphic>
+      </p:graphicFrame>
+      <p:graphicFrame>
+        <p:nvGraphicFramePr>
+          <p:cNvPr id="21" name=""/>
+          <p:cNvGraphicFramePr/>
+          <p:nvPr/>
+        </p:nvGraphicFramePr>
+        <p:xfrm>
+          <a:off xmlns:a="http://schemas.openxmlformats.org/drawingml/2006/main" x="5295900" y="4848225"/>
+          <a:ext xmlns:a="http://schemas.openxmlformats.org/drawingml/2006/main" cx="6286500" cy="838200"/>
+        </p:xfrm>
+        <a:graphic xmlns:a="http://schemas.openxmlformats.org/drawingml/2006/main">
+          <a:graphicData uri="http://schemas.openxmlformats.org/drawingml/2006/table">
+            <a:tbl>
+              <a:tblPr/>
+              <a:tblGrid>
+                <a:gridCol w="2343150"/>
+                <a:gridCol w="1304925"/>
+                <a:gridCol w="1304925"/>
+                <a:gridCol w="1333500"/>
+              </a:tblGrid>
+              <a:tr h="419100">
+                <a:tc>
+                  <a:txBody>
+                    <a:bodyPr/>
+                    <a:lstStyle/>
+                    <a:p>
+                      <a:r>
+                        <a:rPr sz="1425" b="0">
+                          <a:solidFill>
+                            <a:srgbClr val="B3C6B8"/>
+                          </a:solidFill>
+                          <a:latin typeface="Helvetica Neue"/>
+                          <a:ea typeface="Helvetica Neue"/>
+                          <a:cs typeface="Helvetica Neue"/>
+                        </a:rPr>
+                        <a:t>Score PSI</a:t>
+                      </a:r>
+                    </a:p>
+                  </a:txBody>
+                  <a:tcPr marL="91440" marR="91440" marT="45720" marB="45720">
+                    <a:lnL w="0">
+                      <a:solidFill>
+                        <a:srgbClr val="173F31"/>
+                      </a:solidFill>
+                    </a:lnL>
+                    <a:lnR w="0">
+                      <a:solidFill>
+                        <a:srgbClr val="173F31"/>
+                      </a:solidFill>
+                    </a:lnR>
+                    <a:lnT w="0">
+                      <a:solidFill>
+                        <a:srgbClr val="173F31"/>
+                      </a:solidFill>
+                    </a:lnT>
+                    <a:lnB w="0">
+                      <a:solidFill>
+                        <a:srgbClr val="173F31"/>
+                      </a:solidFill>
+                    </a:lnB>
+                    <a:solidFill>
+                      <a:srgbClr val="173F31"/>
+                    </a:solidFill>
+                  </a:tcPr>
+                </a:tc>
+                <a:tc>
+                  <a:txBody>
+                    <a:bodyPr/>
+                    <a:lstStyle/>
+                    <a:p>
+                      <a:r>
+                        <a:rPr sz="1425" b="0">
+                          <a:solidFill>
+                            <a:srgbClr val="B3C6B8"/>
+                          </a:solidFill>
+                          <a:latin typeface="Helvetica Neue"/>
+                          <a:ea typeface="Helvetica Neue"/>
+                          <a:cs typeface="Helvetica Neue"/>
+                        </a:rPr>
+                        <a:t>Logistic</a:t>
+                      </a:r>
+                    </a:p>
+                  </a:txBody>
+                  <a:tcPr marL="91440" marR="91440" marT="45720" marB="45720">
+                    <a:lnL w="0">
+                      <a:solidFill>
+                        <a:srgbClr val="173F31"/>
+                      </a:solidFill>
+                    </a:lnL>
+                    <a:lnR w="0">
+                      <a:solidFill>
+                        <a:srgbClr val="173F31"/>
+                      </a:solidFill>
+                    </a:lnR>
+                    <a:lnT w="0">
+                      <a:solidFill>
+                        <a:srgbClr val="173F31"/>
+                      </a:solidFill>
+                    </a:lnT>
+                    <a:lnB w="0">
+                      <a:solidFill>
+                        <a:srgbClr val="173F31"/>
+                      </a:solidFill>
+                    </a:lnB>
+                    <a:solidFill>
+                      <a:srgbClr val="173F31"/>
+                    </a:solidFill>
+                  </a:tcPr>
+                </a:tc>
+                <a:tc>
+                  <a:txBody>
+                    <a:bodyPr/>
+                    <a:lstStyle/>
+                    <a:p>
+                      <a:r>
+                        <a:rPr sz="1425" b="0">
+                          <a:solidFill>
+                            <a:srgbClr val="B3C6B8"/>
+                          </a:solidFill>
+                          <a:latin typeface="Helvetica Neue"/>
+                          <a:ea typeface="Helvetica Neue"/>
+                          <a:cs typeface="Helvetica Neue"/>
+                        </a:rPr>
+                        <a:t>Forest</a:t>
+                      </a:r>
+                    </a:p>
+                  </a:txBody>
+                  <a:tcPr marL="91440" marR="91440" marT="45720" marB="45720">
+                    <a:lnL w="0">
+                      <a:solidFill>
+                        <a:srgbClr val="173F31"/>
+                      </a:solidFill>
+                    </a:lnL>
+                    <a:lnR w="0">
+                      <a:solidFill>
+                        <a:srgbClr val="173F31"/>
+                      </a:solidFill>
+                    </a:lnR>
+                    <a:lnT w="0">
+                      <a:solidFill>
+                        <a:srgbClr val="173F31"/>
+                      </a:solidFill>
+                    </a:lnT>
+                    <a:lnB w="0">
+                      <a:solidFill>
+                        <a:srgbClr val="173F31"/>
+                      </a:solidFill>
+                    </a:lnB>
+                    <a:solidFill>
+                      <a:srgbClr val="173F31"/>
+                    </a:solidFill>
+                  </a:tcPr>
+                </a:tc>
+                <a:tc>
+                  <a:txBody>
+                    <a:bodyPr/>
+                    <a:lstStyle/>
+                    <a:p>
+                      <a:r>
+                        <a:rPr sz="1425" b="0">
+                          <a:solidFill>
+                            <a:srgbClr val="B3C6B8"/>
+                          </a:solidFill>
+                          <a:latin typeface="Helvetica Neue"/>
+                          <a:ea typeface="Helvetica Neue"/>
+                          <a:cs typeface="Helvetica Neue"/>
+                        </a:rPr>
+                        <a:t>XGBoost</a:t>
+                      </a:r>
+                    </a:p>
+                  </a:txBody>
+                  <a:tcPr marL="91440" marR="91440" marT="45720" marB="45720">
+                    <a:lnL w="0">
+                      <a:solidFill>
+                        <a:srgbClr val="173F31"/>
+                      </a:solidFill>
+                    </a:lnL>
+                    <a:lnR w="0">
+                      <a:solidFill>
+                        <a:srgbClr val="173F31"/>
+                      </a:solidFill>
+                    </a:lnR>
+                    <a:lnT w="0">
+                      <a:solidFill>
+                        <a:srgbClr val="173F31"/>
+                      </a:solidFill>
+                    </a:lnT>
+                    <a:lnB w="0">
+                      <a:solidFill>
+                        <a:srgbClr val="173F31"/>
+                      </a:solidFill>
+                    </a:lnB>
+                    <a:solidFill>
+                      <a:srgbClr val="173F31"/>
+                    </a:solidFill>
+                  </a:tcPr>
+                </a:tc>
+              </a:tr>
+              <a:tr h="419100">
+                <a:tc>
+                  <a:txBody>
+                    <a:bodyPr/>
+                    <a:lstStyle/>
+                    <a:p>
+                      <a:r>
+                        <a:rPr sz="1275" b="0">
+                          <a:solidFill>
+                            <a:srgbClr val="F7F5F0"/>
+                          </a:solidFill>
+                          <a:latin typeface="Helvetica Neue"/>
+                          <a:ea typeface="Helvetica Neue"/>
+                          <a:cs typeface="Helvetica Neue"/>
+                        </a:rPr>
+                        <a:t>Validation to test</a:t>
+                      </a:r>
+                    </a:p>
+                  </a:txBody>
+                  <a:tcPr marL="91440" marR="91440" marT="45720" marB="45720">
+                    <a:lnL w="0">
+                      <a:solidFill>
+                        <a:srgbClr val="173F31"/>
+                      </a:solidFill>
+                    </a:lnL>
+                    <a:lnR w="0">
+                      <a:solidFill>
+                        <a:srgbClr val="173F31"/>
+                      </a:solidFill>
+                    </a:lnR>
+                    <a:lnT w="0">
+                      <a:solidFill>
+                        <a:srgbClr val="173F31"/>
+                      </a:solidFill>
+                    </a:lnT>
+                    <a:lnB w="0">
+                      <a:solidFill>
+                        <a:srgbClr val="173F31"/>
+                      </a:solidFill>
+                    </a:lnB>
+                    <a:solidFill>
+                      <a:srgbClr val="173F31"/>
+                    </a:solidFill>
+                  </a:tcPr>
+                </a:tc>
+                <a:tc>
+                  <a:txBody>
+                    <a:bodyPr/>
+                    <a:lstStyle/>
+                    <a:p>
+                      <a:r>
+                        <a:rPr sz="1950" b="0">
+                          <a:solidFill>
+                            <a:srgbClr val="F7F5F0"/>
+                          </a:solidFill>
+                          <a:latin typeface="Helvetica Neue"/>
+                          <a:ea typeface="Helvetica Neue"/>
+                          <a:cs typeface="Helvetica Neue"/>
+                        </a:rPr>
+                        <a:t>0.029</a:t>
+                      </a:r>
+                    </a:p>
+                  </a:txBody>
+                  <a:tcPr marL="91440" marR="91440" marT="45720" marB="45720">
+                    <a:lnL w="0">
+                      <a:solidFill>
+                        <a:srgbClr val="173F31"/>
+                      </a:solidFill>
+                    </a:lnL>
+                    <a:lnR w="0">
+                      <a:solidFill>
+                        <a:srgbClr val="173F31"/>
+                      </a:solidFill>
+                    </a:lnR>
+                    <a:lnT w="0">
+                      <a:solidFill>
+                        <a:srgbClr val="173F31"/>
+                      </a:solidFill>
+                    </a:lnT>
+                    <a:lnB w="0">
+                      <a:solidFill>
+                        <a:srgbClr val="173F31"/>
+                      </a:solidFill>
+                    </a:lnB>
+                    <a:solidFill>
+                      <a:srgbClr val="173F31"/>
+                    </a:solidFill>
+                  </a:tcPr>
+                </a:tc>
+                <a:tc>
+                  <a:txBody>
+                    <a:bodyPr/>
+                    <a:lstStyle/>
+                    <a:p>
+                      <a:r>
+                        <a:rPr sz="1950" b="0">
+                          <a:solidFill>
+                            <a:srgbClr val="F7F5F0"/>
+                          </a:solidFill>
+                          <a:latin typeface="Helvetica Neue"/>
+                          <a:ea typeface="Helvetica Neue"/>
+                          <a:cs typeface="Helvetica Neue"/>
+                        </a:rPr>
+                        <a:t>0.012</a:t>
+                      </a:r>
+                    </a:p>
+                  </a:txBody>
+                  <a:tcPr marL="91440" marR="91440" marT="45720" marB="45720">
+                    <a:lnL w="0">
+                      <a:solidFill>
+                        <a:srgbClr val="173F31"/>
+                      </a:solidFill>
+                    </a:lnL>
+                    <a:lnR w="0">
+                      <a:solidFill>
+                        <a:srgbClr val="173F31"/>
+                      </a:solidFill>
+                    </a:lnR>
+                    <a:lnT w="0">
+                      <a:solidFill>
+                        <a:srgbClr val="173F31"/>
+                      </a:solidFill>
+                    </a:lnT>
+                    <a:lnB w="0">
+                      <a:solidFill>
+                        <a:srgbClr val="173F31"/>
+                      </a:solidFill>
+                    </a:lnB>
+                    <a:solidFill>
+                      <a:srgbClr val="173F31"/>
+                    </a:solidFill>
+                  </a:tcPr>
+                </a:tc>
+                <a:tc>
+                  <a:txBody>
+                    <a:bodyPr/>
+                    <a:lstStyle/>
+                    <a:p>
+                      <a:r>
+                        <a:rPr sz="1950" b="0">
+                          <a:solidFill>
+                            <a:srgbClr val="F7F5F0"/>
+                          </a:solidFill>
+                          <a:latin typeface="Helvetica Neue"/>
+                          <a:ea typeface="Helvetica Neue"/>
+                          <a:cs typeface="Helvetica Neue"/>
+                        </a:rPr>
+                        <a:t>0.011</a:t>
+                      </a:r>
+                    </a:p>
+                  </a:txBody>
+                  <a:tcPr marL="91440" marR="91440" marT="45720" marB="45720">
+                    <a:lnL w="0">
+                      <a:solidFill>
+                        <a:srgbClr val="173F31"/>
+                      </a:solidFill>
+                    </a:lnL>
+                    <a:lnR w="0">
+                      <a:solidFill>
+                        <a:srgbClr val="173F31"/>
+                      </a:solidFill>
+                    </a:lnR>
+                    <a:lnT w="0">
+                      <a:solidFill>
+                        <a:srgbClr val="173F31"/>
+                      </a:solidFill>
+                    </a:lnT>
+                    <a:lnB w="0">
+                      <a:solidFill>
+                        <a:srgbClr val="173F31"/>
+                      </a:solidFill>
+                    </a:lnB>
+                    <a:solidFill>
+                      <a:srgbClr val="173F31"/>
+                    </a:solidFill>
+                  </a:tcPr>
+                </a:tc>
+              </a:tr>
+            </a:tbl>
+          </a:graphicData>
+        </a:graphic>
+      </p:graphicFrame>
       <p:sp>
         <p:nvSpPr>
-          <p:cNvPr id="7" name="">
+          <p:cNvPr id="11" name="">
             <a:extLst xmlns:a="http://schemas.openxmlformats.org/drawingml/2006/main">
               <a:ext uri="{FF2B5EF4-FFF2-40B4-BE49-F238E27FC236}">
-                <a16:creationId xmlns:a16="http://schemas.microsoft.com/office/drawing/2014/main" id="{9DF5C56F-355C-47E8-A5C3-0083C61943E1}"/>
+                <a16:creationId xmlns:a16="http://schemas.microsoft.com/office/drawing/2014/main" id="{E98BD841-E863-45E0-A4A4-911A633005DD}"/>
               </a:ext>
             </a:extLst>
           </p:cNvPr>
@@ -2113,8 +3290,8 @@
         </p:nvSpPr>
         <p:spPr>
           <a:xfrm xmlns:a="http://schemas.openxmlformats.org/drawingml/2006/main">
-            <a:off x="590550" y="304800"/>
-            <a:ext cx="10001250" cy="247650"/>
+            <a:off x="619125" y="6210300"/>
+            <a:ext cx="10953750" cy="466725"/>
           </a:xfrm>
           <a:prstGeom xmlns:a="http://schemas.openxmlformats.org/drawingml/2006/main" prst="rect">
             <a:avLst/>
@@ -2131,9 +3308,9 @@
           <a:lstStyle xmlns:a="http://schemas.openxmlformats.org/drawingml/2006/main"/>
           <a:p xmlns:a="http://schemas.openxmlformats.org/drawingml/2006/main">
             <a:pPr>
-              <a:defRPr sz="1200" b="0">
-                <a:solidFill>
-                  <a:srgbClr val="617266"/>
+              <a:defRPr sz="1425" b="0">
+                <a:solidFill>
+                  <a:srgbClr val="B3C6B8"/>
                 </a:solidFill>
                 <a:latin typeface="Helvetica Neue"/>
                 <a:ea typeface="Helvetica Neue"/>
@@ -2141,585 +3318,15 @@
               </a:defRPr>
             </a:pPr>
             <a:r>
-              <a:rPr sz="1200" b="0">
-                <a:solidFill>
-                  <a:srgbClr val="617266"/>
+              <a:rPr sz="1425" b="0">
+                <a:solidFill>
+                  <a:srgbClr val="B3C6B8"/>
                 </a:solidFill>
                 <a:latin typeface="Helvetica Neue"/>
                 <a:ea typeface="Helvetica Neue"/>
                 <a:cs typeface="Helvetica Neue"/>
               </a:rPr>
-              <a:t>FOOTBALL RECRUITMENT SCORING</a:t>
-            </a:r>
-          </a:p>
-        </p:txBody>
-      </p:sp>
-      <p:sp>
-        <p:nvSpPr>
-          <p:cNvPr id="2" name="">
-            <a:extLst xmlns:a="http://schemas.openxmlformats.org/drawingml/2006/main">
-              <a:ext uri="{FF2B5EF4-FFF2-40B4-BE49-F238E27FC236}">
-                <a16:creationId xmlns:a16="http://schemas.microsoft.com/office/drawing/2014/main" id="{218B6730-0847-4196-9F8D-81091CACA3A5}"/>
-              </a:ext>
-            </a:extLst>
-          </p:cNvPr>
-          <p:cNvSpPr>
-            <a:spLocks xmlns:a="http://schemas.openxmlformats.org/drawingml/2006/main" noGrp="1"/>
-          </p:cNvSpPr>
-          <p:nvPr/>
-        </p:nvSpPr>
-        <p:spPr>
-          <a:xfrm xmlns:a="http://schemas.openxmlformats.org/drawingml/2006/main">
-            <a:off x="590550" y="828675"/>
-            <a:ext cx="11049000" cy="809625"/>
-          </a:xfrm>
-          <a:prstGeom xmlns:a="http://schemas.openxmlformats.org/drawingml/2006/main" prst="rect">
-            <a:avLst/>
-          </a:prstGeom>
-          <a:noFill xmlns:a="http://schemas.openxmlformats.org/drawingml/2006/main"/>
-          <a:ln xmlns:a="http://schemas.openxmlformats.org/drawingml/2006/main" w="0">
-            <a:noFill/>
-          </a:ln>
-        </p:spPr>
-        <p:txBody>
-          <a:bodyPr xmlns:a="http://schemas.openxmlformats.org/drawingml/2006/main">
-            <a:noAutofit/>
-          </a:bodyPr>
-          <a:lstStyle xmlns:a="http://schemas.openxmlformats.org/drawingml/2006/main"/>
-          <a:p xmlns:a="http://schemas.openxmlformats.org/drawingml/2006/main">
-            <a:pPr>
-              <a:defRPr sz="3450" b="0">
-                <a:solidFill>
-                  <a:srgbClr val="203F30"/>
-                </a:solidFill>
-                <a:latin typeface="Helvetica Neue"/>
-                <a:ea typeface="Helvetica Neue"/>
-                <a:cs typeface="Helvetica Neue"/>
-              </a:defRPr>
-            </a:pPr>
-            <a:r>
-              <a:rPr sz="3450" b="0">
-                <a:solidFill>
-                  <a:srgbClr val="203F30"/>
-                </a:solidFill>
-                <a:latin typeface="Helvetica Neue"/>
-                <a:ea typeface="Helvetica Neue"/>
-                <a:cs typeface="Helvetica Neue"/>
-              </a:rPr>
-              <a:t>Sensitivity to small input changes</a:t>
-            </a:r>
-          </a:p>
-        </p:txBody>
-      </p:sp>
-      <p:sp>
-        <p:nvSpPr>
-          <p:cNvPr id="3" name="">
-            <a:extLst xmlns:a="http://schemas.openxmlformats.org/drawingml/2006/main">
-              <a:ext uri="{FF2B5EF4-FFF2-40B4-BE49-F238E27FC236}">
-                <a16:creationId xmlns:a16="http://schemas.microsoft.com/office/drawing/2014/main" id="{3BB6B80A-4021-4C32-A0E5-FD03D775012D}"/>
-              </a:ext>
-            </a:extLst>
-          </p:cNvPr>
-          <p:cNvSpPr>
-            <a:spLocks xmlns:a="http://schemas.openxmlformats.org/drawingml/2006/main" noGrp="1"/>
-          </p:cNvSpPr>
-          <p:nvPr/>
-        </p:nvSpPr>
-        <p:spPr>
-          <a:xfrm xmlns:a="http://schemas.openxmlformats.org/drawingml/2006/main">
-            <a:off x="11049000" y="6286500"/>
-            <a:ext cx="571500" cy="238125"/>
-          </a:xfrm>
-          <a:prstGeom xmlns:a="http://schemas.openxmlformats.org/drawingml/2006/main" prst="rect">
-            <a:avLst/>
-          </a:prstGeom>
-          <a:noFill xmlns:a="http://schemas.openxmlformats.org/drawingml/2006/main"/>
-          <a:ln xmlns:a="http://schemas.openxmlformats.org/drawingml/2006/main" w="0">
-            <a:noFill/>
-          </a:ln>
-        </p:spPr>
-        <p:txBody>
-          <a:bodyPr xmlns:a="http://schemas.openxmlformats.org/drawingml/2006/main">
-            <a:noAutofit/>
-          </a:bodyPr>
-          <a:lstStyle xmlns:a="http://schemas.openxmlformats.org/drawingml/2006/main"/>
-          <a:p xmlns:a="http://schemas.openxmlformats.org/drawingml/2006/main">
-            <a:pPr>
-              <a:defRPr sz="1275" b="0">
-                <a:solidFill>
-                  <a:srgbClr val="617266"/>
-                </a:solidFill>
-                <a:latin typeface="Helvetica Neue"/>
-                <a:ea typeface="Helvetica Neue"/>
-                <a:cs typeface="Helvetica Neue"/>
-              </a:defRPr>
-            </a:pPr>
-            <a:r>
-              <a:rPr sz="1275" b="0">
-                <a:solidFill>
-                  <a:srgbClr val="617266"/>
-                </a:solidFill>
-                <a:latin typeface="Helvetica Neue"/>
-                <a:ea typeface="Helvetica Neue"/>
-                <a:cs typeface="Helvetica Neue"/>
-              </a:rPr>
-              <a:t>2/2</a:t>
-            </a:r>
-          </a:p>
-        </p:txBody>
-      </p:sp>
-      <p:graphicFrame>
-        <p:nvGraphicFramePr>
-          <p:cNvPr id="10" name=""/>
-          <p:cNvGraphicFramePr/>
-          <p:nvPr/>
-        </p:nvGraphicFramePr>
-        <p:xfrm>
-          <a:off xmlns:a="http://schemas.openxmlformats.org/drawingml/2006/main" x="590550" y="1847850"/>
-          <a:ext xmlns:a="http://schemas.openxmlformats.org/drawingml/2006/main" cx="10934700" cy="2476500"/>
-        </p:xfrm>
-        <a:graphic xmlns:a="http://schemas.openxmlformats.org/drawingml/2006/main">
-          <a:graphicData uri="http://schemas.openxmlformats.org/drawingml/2006/table">
-            <a:tbl>
-              <a:tblPr/>
-              <a:tblGrid>
-                <a:gridCol w="3714750"/>
-                <a:gridCol w="4095750"/>
-                <a:gridCol w="3124200"/>
-              </a:tblGrid>
-              <a:tr h="619125">
-                <a:tc>
-                  <a:txBody>
-                    <a:bodyPr/>
-                    <a:lstStyle/>
-                    <a:p>
-                      <a:r>
-                        <a:rPr sz="1800" b="1">
-                          <a:solidFill>
-                            <a:srgbClr val="203F30"/>
-                          </a:solidFill>
-                          <a:latin typeface="Helvetica Neue"/>
-                          <a:ea typeface="Helvetica Neue"/>
-                          <a:cs typeface="Helvetica Neue"/>
-                        </a:rPr>
-                        <a:t>Model</a:t>
-                      </a:r>
-                    </a:p>
-                  </a:txBody>
-                  <a:tcPr marL="91440" marR="91440" marT="45720" marB="45720">
-                    <a:solidFill>
-                      <a:srgbClr val="E8ECE3"/>
-                    </a:solidFill>
-                  </a:tcPr>
-                </a:tc>
-                <a:tc>
-                  <a:txBody>
-                    <a:bodyPr/>
-                    <a:lstStyle/>
-                    <a:p>
-                      <a:r>
-                        <a:rPr sz="1800" b="1">
-                          <a:solidFill>
-                            <a:srgbClr val="203F30"/>
-                          </a:solidFill>
-                          <a:latin typeface="Helvetica Neue"/>
-                          <a:ea typeface="Helvetica Neue"/>
-                          <a:cs typeface="Helvetica Neue"/>
-                        </a:rPr>
-                        <a:t>Mean score change</a:t>
-                      </a:r>
-                    </a:p>
-                  </a:txBody>
-                  <a:tcPr marL="91440" marR="91440" marT="45720" marB="45720">
-                    <a:solidFill>
-                      <a:srgbClr val="E8ECE3"/>
-                    </a:solidFill>
-                  </a:tcPr>
-                </a:tc>
-                <a:tc>
-                  <a:txBody>
-                    <a:bodyPr/>
-                    <a:lstStyle/>
-                    <a:p>
-                      <a:r>
-                        <a:rPr sz="1800" b="1">
-                          <a:solidFill>
-                            <a:srgbClr val="203F30"/>
-                          </a:solidFill>
-                          <a:latin typeface="Helvetica Neue"/>
-                          <a:ea typeface="Helvetica Neue"/>
-                          <a:cs typeface="Helvetica Neue"/>
-                        </a:rPr>
-                        <a:t>Score PSI</a:t>
-                      </a:r>
-                    </a:p>
-                  </a:txBody>
-                  <a:tcPr marL="91440" marR="91440" marT="45720" marB="45720">
-                    <a:solidFill>
-                      <a:srgbClr val="E8ECE3"/>
-                    </a:solidFill>
-                  </a:tcPr>
-                </a:tc>
-              </a:tr>
-              <a:tr h="619125">
-                <a:tc>
-                  <a:txBody>
-                    <a:bodyPr/>
-                    <a:lstStyle/>
-                    <a:p>
-                      <a:r>
-                        <a:rPr sz="2100" b="0">
-                          <a:solidFill>
-                            <a:srgbClr val="203F30"/>
-                          </a:solidFill>
-                          <a:latin typeface="Helvetica Neue"/>
-                          <a:ea typeface="Helvetica Neue"/>
-                          <a:cs typeface="Helvetica Neue"/>
-                        </a:rPr>
-                        <a:t>Logistic</a:t>
-                      </a:r>
-                    </a:p>
-                  </a:txBody>
-                  <a:tcPr marL="91440" marR="91440" marT="45720" marB="45720">
-                    <a:solidFill>
-                      <a:srgbClr val="F7F6F0"/>
-                    </a:solidFill>
-                  </a:tcPr>
-                </a:tc>
-                <a:tc>
-                  <a:txBody>
-                    <a:bodyPr/>
-                    <a:lstStyle/>
-                    <a:p>
-                      <a:r>
-                        <a:rPr sz="2100" b="0">
-                          <a:solidFill>
-                            <a:srgbClr val="203F30"/>
-                          </a:solidFill>
-                          <a:latin typeface="Helvetica Neue"/>
-                          <a:ea typeface="Helvetica Neue"/>
-                          <a:cs typeface="Helvetica Neue"/>
-                        </a:rPr>
-                        <a:t>0.10 pp</a:t>
-                      </a:r>
-                    </a:p>
-                  </a:txBody>
-                  <a:tcPr marL="91440" marR="91440" marT="45720" marB="45720">
-                    <a:solidFill>
-                      <a:srgbClr val="F7F6F0"/>
-                    </a:solidFill>
-                  </a:tcPr>
-                </a:tc>
-                <a:tc>
-                  <a:txBody>
-                    <a:bodyPr/>
-                    <a:lstStyle/>
-                    <a:p>
-                      <a:r>
-                        <a:rPr sz="2100" b="0">
-                          <a:solidFill>
-                            <a:srgbClr val="203F30"/>
-                          </a:solidFill>
-                          <a:latin typeface="Helvetica Neue"/>
-                          <a:ea typeface="Helvetica Neue"/>
-                          <a:cs typeface="Helvetica Neue"/>
-                        </a:rPr>
-                        <a:t>0.029</a:t>
-                      </a:r>
-                    </a:p>
-                  </a:txBody>
-                  <a:tcPr marL="91440" marR="91440" marT="45720" marB="45720">
-                    <a:solidFill>
-                      <a:srgbClr val="F7F6F0"/>
-                    </a:solidFill>
-                  </a:tcPr>
-                </a:tc>
-              </a:tr>
-              <a:tr h="619125">
-                <a:tc>
-                  <a:txBody>
-                    <a:bodyPr/>
-                    <a:lstStyle/>
-                    <a:p>
-                      <a:r>
-                        <a:rPr sz="2100" b="0">
-                          <a:solidFill>
-                            <a:srgbClr val="203F30"/>
-                          </a:solidFill>
-                          <a:latin typeface="Helvetica Neue"/>
-                          <a:ea typeface="Helvetica Neue"/>
-                          <a:cs typeface="Helvetica Neue"/>
-                        </a:rPr>
-                        <a:t>Random Forest</a:t>
-                      </a:r>
-                    </a:p>
-                  </a:txBody>
-                  <a:tcPr marL="91440" marR="91440" marT="45720" marB="45720">
-                    <a:solidFill>
-                      <a:srgbClr val="F7F6F0"/>
-                    </a:solidFill>
-                  </a:tcPr>
-                </a:tc>
-                <a:tc>
-                  <a:txBody>
-                    <a:bodyPr/>
-                    <a:lstStyle/>
-                    <a:p>
-                      <a:r>
-                        <a:rPr sz="2100" b="0">
-                          <a:solidFill>
-                            <a:srgbClr val="203F30"/>
-                          </a:solidFill>
-                          <a:latin typeface="Helvetica Neue"/>
-                          <a:ea typeface="Helvetica Neue"/>
-                          <a:cs typeface="Helvetica Neue"/>
-                        </a:rPr>
-                        <a:t>0.23 pp</a:t>
-                      </a:r>
-                    </a:p>
-                  </a:txBody>
-                  <a:tcPr marL="91440" marR="91440" marT="45720" marB="45720">
-                    <a:solidFill>
-                      <a:srgbClr val="F7F6F0"/>
-                    </a:solidFill>
-                  </a:tcPr>
-                </a:tc>
-                <a:tc>
-                  <a:txBody>
-                    <a:bodyPr/>
-                    <a:lstStyle/>
-                    <a:p>
-                      <a:r>
-                        <a:rPr sz="2100" b="0">
-                          <a:solidFill>
-                            <a:srgbClr val="203F30"/>
-                          </a:solidFill>
-                          <a:latin typeface="Helvetica Neue"/>
-                          <a:ea typeface="Helvetica Neue"/>
-                          <a:cs typeface="Helvetica Neue"/>
-                        </a:rPr>
-                        <a:t>0.012</a:t>
-                      </a:r>
-                    </a:p>
-                  </a:txBody>
-                  <a:tcPr marL="91440" marR="91440" marT="45720" marB="45720">
-                    <a:solidFill>
-                      <a:srgbClr val="F7F6F0"/>
-                    </a:solidFill>
-                  </a:tcPr>
-                </a:tc>
-              </a:tr>
-              <a:tr h="619125">
-                <a:tc>
-                  <a:txBody>
-                    <a:bodyPr/>
-                    <a:lstStyle/>
-                    <a:p>
-                      <a:r>
-                        <a:rPr sz="2100" b="0">
-                          <a:solidFill>
-                            <a:srgbClr val="203F30"/>
-                          </a:solidFill>
-                          <a:latin typeface="Helvetica Neue"/>
-                          <a:ea typeface="Helvetica Neue"/>
-                          <a:cs typeface="Helvetica Neue"/>
-                        </a:rPr>
-                        <a:t>XGBoost</a:t>
-                      </a:r>
-                    </a:p>
-                  </a:txBody>
-                  <a:tcPr marL="91440" marR="91440" marT="45720" marB="45720">
-                    <a:solidFill>
-                      <a:srgbClr val="F7F6F0"/>
-                    </a:solidFill>
-                  </a:tcPr>
-                </a:tc>
-                <a:tc>
-                  <a:txBody>
-                    <a:bodyPr/>
-                    <a:lstStyle/>
-                    <a:p>
-                      <a:r>
-                        <a:rPr sz="2100" b="0">
-                          <a:solidFill>
-                            <a:srgbClr val="203F30"/>
-                          </a:solidFill>
-                          <a:latin typeface="Helvetica Neue"/>
-                          <a:ea typeface="Helvetica Neue"/>
-                          <a:cs typeface="Helvetica Neue"/>
-                        </a:rPr>
-                        <a:t>0.37 pp</a:t>
-                      </a:r>
-                    </a:p>
-                  </a:txBody>
-                  <a:tcPr marL="91440" marR="91440" marT="45720" marB="45720">
-                    <a:solidFill>
-                      <a:srgbClr val="F7F6F0"/>
-                    </a:solidFill>
-                  </a:tcPr>
-                </a:tc>
-                <a:tc>
-                  <a:txBody>
-                    <a:bodyPr/>
-                    <a:lstStyle/>
-                    <a:p>
-                      <a:r>
-                        <a:rPr sz="2100" b="0">
-                          <a:solidFill>
-                            <a:srgbClr val="203F30"/>
-                          </a:solidFill>
-                          <a:latin typeface="Helvetica Neue"/>
-                          <a:ea typeface="Helvetica Neue"/>
-                          <a:cs typeface="Helvetica Neue"/>
-                        </a:rPr>
-                        <a:t>0.011</a:t>
-                      </a:r>
-                    </a:p>
-                  </a:txBody>
-                  <a:tcPr marL="91440" marR="91440" marT="45720" marB="45720">
-                    <a:solidFill>
-                      <a:srgbClr val="F7F6F0"/>
-                    </a:solidFill>
-                  </a:tcPr>
-                </a:tc>
-              </a:tr>
-            </a:tbl>
-          </a:graphicData>
-        </a:graphic>
-      </p:graphicFrame>
-      <p:sp>
-        <p:nvSpPr>
-          <p:cNvPr id="5" name="">
-            <a:extLst xmlns:a="http://schemas.openxmlformats.org/drawingml/2006/main">
-              <a:ext uri="{FF2B5EF4-FFF2-40B4-BE49-F238E27FC236}">
-                <a16:creationId xmlns:a16="http://schemas.microsoft.com/office/drawing/2014/main" id="{DD6BAE9F-1799-4768-BBA5-ACBF7897CD6F}"/>
-              </a:ext>
-            </a:extLst>
-          </p:cNvPr>
-          <p:cNvSpPr>
-            <a:spLocks xmlns:a="http://schemas.openxmlformats.org/drawingml/2006/main" noGrp="1"/>
-          </p:cNvSpPr>
-          <p:nvPr/>
-        </p:nvSpPr>
-        <p:spPr>
-          <a:xfrm xmlns:a="http://schemas.openxmlformats.org/drawingml/2006/main">
-            <a:off x="590550" y="4733925"/>
-            <a:ext cx="10934700" cy="476250"/>
-          </a:xfrm>
-          <a:prstGeom xmlns:a="http://schemas.openxmlformats.org/drawingml/2006/main" prst="rect">
-            <a:avLst/>
-          </a:prstGeom>
-          <a:noFill xmlns:a="http://schemas.openxmlformats.org/drawingml/2006/main"/>
-          <a:ln xmlns:a="http://schemas.openxmlformats.org/drawingml/2006/main" w="0">
-            <a:noFill/>
-          </a:ln>
-        </p:spPr>
-        <p:txBody>
-          <a:bodyPr xmlns:a="http://schemas.openxmlformats.org/drawingml/2006/main">
-            <a:noAutofit/>
-          </a:bodyPr>
-          <a:lstStyle xmlns:a="http://schemas.openxmlformats.org/drawingml/2006/main"/>
-          <a:p xmlns:a="http://schemas.openxmlformats.org/drawingml/2006/main">
-            <a:pPr>
-              <a:defRPr sz="2400" b="1">
-                <a:solidFill>
-                  <a:srgbClr val="203F30"/>
-                </a:solidFill>
-                <a:latin typeface="Helvetica Neue"/>
-                <a:ea typeface="Helvetica Neue"/>
-                <a:cs typeface="Helvetica Neue"/>
-              </a:defRPr>
-            </a:pPr>
-            <a:r>
-              <a:rPr sz="2400" b="1">
-                <a:solidFill>
-                  <a:srgbClr val="203F30"/>
-                </a:solidFill>
-                <a:latin typeface="Helvetica Neue"/>
-                <a:ea typeface="Helvetica Neue"/>
-                <a:cs typeface="Helvetica Neue"/>
-              </a:rPr>
-              <a:t>Logistic scores move least in this noise test</a:t>
-            </a:r>
-          </a:p>
-        </p:txBody>
-      </p:sp>
-      <p:sp>
-        <p:nvSpPr>
-          <p:cNvPr id="6" name="">
-            <a:extLst xmlns:a="http://schemas.openxmlformats.org/drawingml/2006/main">
-              <a:ext uri="{FF2B5EF4-FFF2-40B4-BE49-F238E27FC236}">
-                <a16:creationId xmlns:a16="http://schemas.microsoft.com/office/drawing/2014/main" id="{E75D363F-597D-402A-B8E9-E90B4577B773}"/>
-              </a:ext>
-            </a:extLst>
-          </p:cNvPr>
-          <p:cNvSpPr>
-            <a:spLocks xmlns:a="http://schemas.openxmlformats.org/drawingml/2006/main" noGrp="1"/>
-          </p:cNvSpPr>
-          <p:nvPr/>
-        </p:nvSpPr>
-        <p:spPr>
-          <a:xfrm xmlns:a="http://schemas.openxmlformats.org/drawingml/2006/main">
-            <a:off x="590550" y="5334000"/>
-            <a:ext cx="10934700" cy="742950"/>
-          </a:xfrm>
-          <a:prstGeom xmlns:a="http://schemas.openxmlformats.org/drawingml/2006/main" prst="rect">
-            <a:avLst/>
-          </a:prstGeom>
-          <a:noFill xmlns:a="http://schemas.openxmlformats.org/drawingml/2006/main"/>
-          <a:ln xmlns:a="http://schemas.openxmlformats.org/drawingml/2006/main" w="0">
-            <a:noFill/>
-          </a:ln>
-        </p:spPr>
-        <p:txBody>
-          <a:bodyPr xmlns:a="http://schemas.openxmlformats.org/drawingml/2006/main">
-            <a:noAutofit/>
-          </a:bodyPr>
-          <a:lstStyle xmlns:a="http://schemas.openxmlformats.org/drawingml/2006/main"/>
-          <a:p xmlns:a="http://schemas.openxmlformats.org/drawingml/2006/main">
-            <a:pPr>
-              <a:defRPr sz="1875" b="0">
-                <a:solidFill>
-                  <a:srgbClr val="617266"/>
-                </a:solidFill>
-                <a:latin typeface="Helvetica Neue"/>
-                <a:ea typeface="Helvetica Neue"/>
-                <a:cs typeface="Helvetica Neue"/>
-              </a:defRPr>
-            </a:pPr>
-            <a:r>
-              <a:rPr sz="1875" b="0">
-                <a:solidFill>
-                  <a:srgbClr val="617266"/>
-                </a:solidFill>
-                <a:latin typeface="Helvetica Neue"/>
-                <a:ea typeface="Helvetica Neue"/>
-                <a:cs typeface="Helvetica Neue"/>
-              </a:rPr>
-              <a:t>1% training-SD noise on age, height and valuations.</a:t>
-            </a:r>
-          </a:p>
-          <a:p xmlns:a="http://schemas.openxmlformats.org/drawingml/2006/main">
-            <a:pPr>
-              <a:defRPr sz="1875" b="0">
-                <a:solidFill>
-                  <a:srgbClr val="617266"/>
-                </a:solidFill>
-                <a:latin typeface="Helvetica Neue"/>
-                <a:ea typeface="Helvetica Neue"/>
-                <a:cs typeface="Helvetica Neue"/>
-              </a:defRPr>
-            </a:pPr>
-            <a:r>
-              <a:rPr sz="1875" b="0">
-                <a:solidFill>
-                  <a:srgbClr val="617266"/>
-                </a:solidFill>
-                <a:latin typeface="Helvetica Neue"/>
-                <a:ea typeface="Helvetica Neue"/>
-                <a:cs typeface="Helvetica Neue"/>
-              </a:rPr>
-              <a:t>PSI compares validation scores with test scores.</a:t>
+              <a:t>Noise uses 1% of training SD on age, height and valuations. PSI measures score distribution shift.</a:t>
             </a:r>
           </a:p>
         </p:txBody>
@@ -2727,7 +3334,7 @@
     </p:spTree>
     <p:extLst>
       <p:ext uri="{BB962C8B-B14F-4D97-AF65-F5344CB8AC3E}">
-        <p14:creationId xmlns:p14="http://schemas.microsoft.com/office/powerpoint/2010/main" val="148319106"/>
+        <p14:creationId xmlns:p14="http://schemas.microsoft.com/office/powerpoint/2010/main" val="193747441"/>
       </p:ext>
     </p:extLst>
   </p:cSld>

</xml_diff>

<commit_message>
Simplify slide layouts and remove presenter notes
</commit_message>
<xml_diff>
--- a/deliverables/Football stability.pptx
+++ b/deliverables/Football stability.pptx
@@ -2,14 +2,14 @@
 <file path=ppt/presentation.xml><?xml version="1.0" encoding="utf-8"?>
 <p:presentation xmlns:p="http://schemas.openxmlformats.org/presentationml/2006/main">
   <p:sldMasterIdLst>
-    <p:sldMasterId xmlns:r="http://schemas.openxmlformats.org/officeDocument/2006/relationships" id="2147483648" r:id="Ree5de390db304c31"/>
+    <p:sldMasterId xmlns:r="http://schemas.openxmlformats.org/officeDocument/2006/relationships" id="2147483648" r:id="R1af90ecf84c34763"/>
   </p:sldMasterIdLst>
   <p:notesMasterIdLst>
-    <p:notesMasterId xmlns:r="http://schemas.openxmlformats.org/officeDocument/2006/relationships" r:id="R49980c3b292a4ed7"/>
+    <p:notesMasterId xmlns:r="http://schemas.openxmlformats.org/officeDocument/2006/relationships" r:id="R832b78c371984012"/>
   </p:notesMasterIdLst>
   <p:sldIdLst>
-    <p:sldId xmlns:r="http://schemas.openxmlformats.org/officeDocument/2006/relationships" id="256" r:id="Rafd52f288e7b484f"/>
-    <p:sldId xmlns:r="http://schemas.openxmlformats.org/officeDocument/2006/relationships" id="257" r:id="Rd4d430f658ae47c3"/>
+    <p:sldId xmlns:r="http://schemas.openxmlformats.org/officeDocument/2006/relationships" id="256" r:id="Rba859e0d3a364f38"/>
+    <p:sldId xmlns:r="http://schemas.openxmlformats.org/officeDocument/2006/relationships" id="257" r:id="Rd7f504d0cc5a48e9"/>
   </p:sldIdLst>
   <p:sldSz cx="12192000" cy="6858000"/>
   <p:notesSz cx="6858000" cy="9144000"/>
@@ -443,7 +443,7 @@
           <a:lstStyle xmlns:a="http://schemas.openxmlformats.org/drawingml/2006/main"/>
           <a:p xmlns:a="http://schemas.openxmlformats.org/drawingml/2006/main">
             <a:r>
-              <a:t>About 45 seconds. We train on older seasons, validate on 2022 and evaluate on 2023 to 2025. The three models perform similarly, with AUC around 0.80. Logistic regression reaches 0.805 overall. We resample players, keeping their repeated seasons together, 200 times. The paired interval against XGBoost includes zero, so we cannot claim a decisive AUC advantage. Every observed valuation date is strictly before July 1. Missing next-season coverage remains unknown. Source: reports/metrics.csv, reports/bootstrap_auc.csv, reports/paired_auc_comparisons.txt and dataset_final.parquet at https://github.com/RemiBp/football-recruitment-scoring. TabICL reaches 0.811 with a 1500-row training context, so it is reported separately with matched baselines.</a:t>
+              <a:t/>
             </a:r>
           </a:p>
         </p:txBody>
@@ -513,7 +513,7 @@
           <a:lstStyle xmlns:a="http://schemas.openxmlformats.org/drawingml/2006/main"/>
           <a:p xmlns:a="http://schemas.openxmlformats.org/drawingml/2006/main">
             <a:r>
-              <a:t>About 45 seconds. We perturb continuous measurements by one percent of their training standard deviation, using the same noise for all models. Logistic scores change by about 0.10 percentage points on average, versus 0.23 for Random Forest and 0.37 for XGBoost. This supports greater robustness to this specific perturbation. Five random seeds produce small AUC ranges for both tree models. PSI separately measures distribution shift and has no universal pass-fail threshold. We also refit logistic coefficients in 200 player-cluster bootstraps. These checks support considering the simpler model, but fairness and interpretation still need the group review. Source: reports/perturbations.csv, reports/seed_variation.csv, reports/psi.csv and reports/coefficient_intervals.csv at https://github.com/RemiBp/football-recruitment-scoring. Score PSI shown uses validation as its reference. Full feature PSI uses training bins.</a:t>
+              <a:t/>
             </a:r>
           </a:p>
         </p:txBody>
@@ -581,7 +581,7 @@
   </p:cSld>
   <p:clrMap bg1="lt1" tx1="dk1" bg2="lt2" tx2="dk2" accent1="accent1" accent2="accent2" accent3="accent3" accent4="accent4" accent5="accent5" accent6="accent6" hlink="hlink" folHlink="folHlink"/>
   <p:sldLayoutIdLst>
-    <p:sldLayoutId xmlns:r="http://schemas.openxmlformats.org/officeDocument/2006/relationships" id="2147483649" r:id="Rd653b786f089438d"/>
+    <p:sldLayoutId xmlns:r="http://schemas.openxmlformats.org/officeDocument/2006/relationships" id="2147483649" r:id="R1bac07f1dac648a4"/>
   </p:sldLayoutIdLst>
   <p:txStyles>
     <p:titleStyle>
@@ -1683,10 +1683,10 @@
       </p:grpSpPr>
       <p:sp>
         <p:nvSpPr>
-          <p:cNvPr id="13" name="">
+          <p:cNvPr id="10" name="">
             <a:extLst xmlns:a="http://schemas.openxmlformats.org/drawingml/2006/main">
               <a:ext uri="{FF2B5EF4-FFF2-40B4-BE49-F238E27FC236}">
-                <a16:creationId xmlns:a16="http://schemas.microsoft.com/office/drawing/2014/main" id="{EF09187B-207B-484B-B2DF-7184BE94868C}"/>
+                <a16:creationId xmlns:a16="http://schemas.microsoft.com/office/drawing/2014/main" id="{9F84C816-C5A9-4771-B368-ED71FAF17B0C}"/>
               </a:ext>
             </a:extLst>
           </p:cNvPr>
@@ -1697,121 +1697,7 @@
         </p:nvSpPr>
         <p:spPr>
           <a:xfrm xmlns:a="http://schemas.openxmlformats.org/drawingml/2006/main">
-            <a:off x="609600" y="352425"/>
-            <a:ext cx="9525000" cy="285750"/>
-          </a:xfrm>
-          <a:prstGeom xmlns:a="http://schemas.openxmlformats.org/drawingml/2006/main" prst="rect">
-            <a:avLst/>
-          </a:prstGeom>
-          <a:noFill xmlns:a="http://schemas.openxmlformats.org/drawingml/2006/main"/>
-          <a:ln xmlns:a="http://schemas.openxmlformats.org/drawingml/2006/main" w="0">
-            <a:noFill/>
-          </a:ln>
-        </p:spPr>
-        <p:txBody>
-          <a:bodyPr xmlns:a="http://schemas.openxmlformats.org/drawingml/2006/main">
-            <a:noAutofit/>
-          </a:bodyPr>
-          <a:lstStyle xmlns:a="http://schemas.openxmlformats.org/drawingml/2006/main"/>
-          <a:p xmlns:a="http://schemas.openxmlformats.org/drawingml/2006/main">
-            <a:pPr>
-              <a:defRPr sz="1200" b="1">
-                <a:solidFill>
-                  <a:srgbClr val="637267"/>
-                </a:solidFill>
-                <a:latin typeface="Helvetica Neue"/>
-                <a:ea typeface="Helvetica Neue"/>
-                <a:cs typeface="Helvetica Neue"/>
-              </a:defRPr>
-            </a:pPr>
-            <a:r>
-              <a:rPr sz="1200" b="1">
-                <a:solidFill>
-                  <a:srgbClr val="637267"/>
-                </a:solidFill>
-                <a:latin typeface="Helvetica Neue"/>
-                <a:ea typeface="Helvetica Neue"/>
-                <a:cs typeface="Helvetica Neue"/>
-              </a:rPr>
-              <a:t>FOOTBALL RECRUITMENT</a:t>
-            </a:r>
-          </a:p>
-        </p:txBody>
-      </p:sp>
-      <p:sp>
-        <p:nvSpPr>
-          <p:cNvPr id="2" name="">
-            <a:extLst xmlns:a="http://schemas.openxmlformats.org/drawingml/2006/main">
-              <a:ext uri="{FF2B5EF4-FFF2-40B4-BE49-F238E27FC236}">
-                <a16:creationId xmlns:a16="http://schemas.microsoft.com/office/drawing/2014/main" id="{5A1BA1D2-BC2F-4E41-A48C-7A81FCC996C6}"/>
-              </a:ext>
-            </a:extLst>
-          </p:cNvPr>
-          <p:cNvSpPr>
-            <a:spLocks xmlns:a="http://schemas.openxmlformats.org/drawingml/2006/main" noGrp="1"/>
-          </p:cNvSpPr>
-          <p:nvPr/>
-        </p:nvSpPr>
-        <p:spPr>
-          <a:xfrm xmlns:a="http://schemas.openxmlformats.org/drawingml/2006/main">
-            <a:off x="11049000" y="314325"/>
-            <a:ext cx="666750" cy="400050"/>
-          </a:xfrm>
-          <a:prstGeom xmlns:a="http://schemas.openxmlformats.org/drawingml/2006/main" prst="rect">
-            <a:avLst/>
-          </a:prstGeom>
-          <a:noFill xmlns:a="http://schemas.openxmlformats.org/drawingml/2006/main"/>
-          <a:ln xmlns:a="http://schemas.openxmlformats.org/drawingml/2006/main" w="0">
-            <a:noFill/>
-          </a:ln>
-        </p:spPr>
-        <p:txBody>
-          <a:bodyPr xmlns:a="http://schemas.openxmlformats.org/drawingml/2006/main">
-            <a:noAutofit/>
-          </a:bodyPr>
-          <a:lstStyle xmlns:a="http://schemas.openxmlformats.org/drawingml/2006/main"/>
-          <a:p xmlns:a="http://schemas.openxmlformats.org/drawingml/2006/main">
-            <a:pPr>
-              <a:defRPr sz="2100" b="0">
-                <a:solidFill>
-                  <a:srgbClr val="1B4A38"/>
-                </a:solidFill>
-                <a:latin typeface="Georgia"/>
-                <a:ea typeface="Georgia"/>
-                <a:cs typeface="Georgia"/>
-              </a:defRPr>
-            </a:pPr>
-            <a:r>
-              <a:rPr sz="2100" b="0">
-                <a:solidFill>
-                  <a:srgbClr val="1B4A38"/>
-                </a:solidFill>
-                <a:latin typeface="Georgia"/>
-                <a:ea typeface="Georgia"/>
-                <a:cs typeface="Georgia"/>
-              </a:rPr>
-              <a:t>01</a:t>
-            </a:r>
-          </a:p>
-        </p:txBody>
-      </p:sp>
-      <p:sp>
-        <p:nvSpPr>
-          <p:cNvPr id="3" name="">
-            <a:extLst xmlns:a="http://schemas.openxmlformats.org/drawingml/2006/main">
-              <a:ext uri="{FF2B5EF4-FFF2-40B4-BE49-F238E27FC236}">
-                <a16:creationId xmlns:a16="http://schemas.microsoft.com/office/drawing/2014/main" id="{1EB127B0-FE88-4F25-B8EC-9A34C243988E}"/>
-              </a:ext>
-            </a:extLst>
-          </p:cNvPr>
-          <p:cNvSpPr>
-            <a:spLocks xmlns:a="http://schemas.openxmlformats.org/drawingml/2006/main" noGrp="1"/>
-          </p:cNvSpPr>
-          <p:nvPr/>
-        </p:nvSpPr>
-        <p:spPr>
-          <a:xfrm xmlns:a="http://schemas.openxmlformats.org/drawingml/2006/main">
-            <a:off x="571500" y="981075"/>
+            <a:off x="571500" y="838200"/>
             <a:ext cx="11049000" cy="876300"/>
           </a:xfrm>
           <a:prstGeom xmlns:a="http://schemas.openxmlformats.org/drawingml/2006/main" prst="rect">
@@ -1854,10 +1740,10 @@
       </p:sp>
       <p:sp>
         <p:nvSpPr>
-          <p:cNvPr id="4" name="">
+          <p:cNvPr id="2" name="">
             <a:extLst xmlns:a="http://schemas.openxmlformats.org/drawingml/2006/main">
               <a:ext uri="{FF2B5EF4-FFF2-40B4-BE49-F238E27FC236}">
-                <a16:creationId xmlns:a16="http://schemas.microsoft.com/office/drawing/2014/main" id="{8CF90081-83A8-4821-A9B1-03802ECEF265}"/>
+                <a16:creationId xmlns:a16="http://schemas.microsoft.com/office/drawing/2014/main" id="{6A2CEB12-D9A7-4712-B141-27BCFDF874D6}"/>
               </a:ext>
             </a:extLst>
           </p:cNvPr>
@@ -1868,7 +1754,7 @@
         </p:nvSpPr>
         <p:spPr>
           <a:xfrm xmlns:a="http://schemas.openxmlformats.org/drawingml/2006/main">
-            <a:off x="619125" y="1905000"/>
+            <a:off x="619125" y="1809750"/>
             <a:ext cx="10572750" cy="400050"/>
           </a:xfrm>
           <a:prstGeom xmlns:a="http://schemas.openxmlformats.org/drawingml/2006/main" prst="rect">
@@ -1911,10 +1797,10 @@
       </p:sp>
       <p:sp>
         <p:nvSpPr>
-          <p:cNvPr id="5" name="">
+          <p:cNvPr id="3" name="">
             <a:extLst xmlns:a="http://schemas.openxmlformats.org/drawingml/2006/main">
               <a:ext uri="{FF2B5EF4-FFF2-40B4-BE49-F238E27FC236}">
-                <a16:creationId xmlns:a16="http://schemas.microsoft.com/office/drawing/2014/main" id="{9463FC83-963F-4A2A-8E0D-131E6EAB99C1}"/>
+                <a16:creationId xmlns:a16="http://schemas.microsoft.com/office/drawing/2014/main" id="{0CF0D825-0D13-4EFB-A0D0-73A3128421FF}"/>
               </a:ext>
             </a:extLst>
           </p:cNvPr>
@@ -1968,10 +1854,10 @@
       </p:sp>
       <p:sp>
         <p:nvSpPr>
-          <p:cNvPr id="6" name="">
+          <p:cNvPr id="4" name="">
             <a:extLst xmlns:a="http://schemas.openxmlformats.org/drawingml/2006/main">
               <a:ext uri="{FF2B5EF4-FFF2-40B4-BE49-F238E27FC236}">
-                <a16:creationId xmlns:a16="http://schemas.microsoft.com/office/drawing/2014/main" id="{4561DBD0-2D67-4625-9F1A-A9C33D32B840}"/>
+                <a16:creationId xmlns:a16="http://schemas.microsoft.com/office/drawing/2014/main" id="{EBE0BEA4-03D3-4387-9963-5DBAC1609AFA}"/>
               </a:ext>
             </a:extLst>
           </p:cNvPr>
@@ -2025,10 +1911,10 @@
       </p:sp>
       <p:sp>
         <p:nvSpPr>
-          <p:cNvPr id="7" name="">
+          <p:cNvPr id="5" name="">
             <a:extLst xmlns:a="http://schemas.openxmlformats.org/drawingml/2006/main">
               <a:ext uri="{FF2B5EF4-FFF2-40B4-BE49-F238E27FC236}">
-                <a16:creationId xmlns:a16="http://schemas.microsoft.com/office/drawing/2014/main" id="{DEC4191C-8B95-4A79-A402-E4C88375E6C9}"/>
+                <a16:creationId xmlns:a16="http://schemas.microsoft.com/office/drawing/2014/main" id="{99F70BAF-77D5-40E0-9793-74D50CC67D3D}"/>
               </a:ext>
             </a:extLst>
           </p:cNvPr>
@@ -2082,10 +1968,10 @@
       </p:sp>
       <p:sp>
         <p:nvSpPr>
-          <p:cNvPr id="8" name="">
+          <p:cNvPr id="6" name="">
             <a:extLst xmlns:a="http://schemas.openxmlformats.org/drawingml/2006/main">
               <a:ext uri="{FF2B5EF4-FFF2-40B4-BE49-F238E27FC236}">
-                <a16:creationId xmlns:a16="http://schemas.microsoft.com/office/drawing/2014/main" id="{C0F8DEA8-E49C-4FE9-8EE2-66F5E17BFEAA}"/>
+                <a16:creationId xmlns:a16="http://schemas.microsoft.com/office/drawing/2014/main" id="{41135633-0E37-4005-86C9-13105C14164F}"/>
               </a:ext>
             </a:extLst>
           </p:cNvPr>
@@ -2139,10 +2025,10 @@
       </p:sp>
       <p:sp>
         <p:nvSpPr>
-          <p:cNvPr id="9" name="">
+          <p:cNvPr id="7" name="">
             <a:extLst xmlns:a="http://schemas.openxmlformats.org/drawingml/2006/main">
               <a:ext uri="{FF2B5EF4-FFF2-40B4-BE49-F238E27FC236}">
-                <a16:creationId xmlns:a16="http://schemas.microsoft.com/office/drawing/2014/main" id="{B549BD61-0A1B-45A4-A3CC-EE6F0A9F8B81}"/>
+                <a16:creationId xmlns:a16="http://schemas.microsoft.com/office/drawing/2014/main" id="{927E6602-AC43-4298-9B24-86D92E681F42}"/>
               </a:ext>
             </a:extLst>
           </p:cNvPr>
@@ -2219,26 +2105,26 @@
       </p:sp>
       <p:graphicFrame>
         <p:nvGraphicFramePr>
-          <p:cNvPr id="22" name="Chart"/>
+          <p:cNvPr id="17" name="Chart"/>
           <p:cNvGraphicFramePr/>
           <p:nvPr/>
         </p:nvGraphicFramePr>
         <p:xfrm>
-          <a:off xmlns:a="http://schemas.openxmlformats.org/drawingml/2006/main" x="4276725" y="2619375"/>
-          <a:ext xmlns:a="http://schemas.openxmlformats.org/drawingml/2006/main" cx="7391400" cy="3162300"/>
+          <a:off xmlns:a="http://schemas.openxmlformats.org/drawingml/2006/main" x="4324350" y="2781300"/>
+          <a:ext xmlns:a="http://schemas.openxmlformats.org/drawingml/2006/main" cx="7181850" cy="3143250"/>
         </p:xfrm>
         <a:graphic xmlns:a="http://schemas.openxmlformats.org/drawingml/2006/main">
           <a:graphicData uri="http://schemas.openxmlformats.org/drawingml/2006/chart">
-            <c:chart xmlns:r="http://schemas.openxmlformats.org/officeDocument/2006/relationships" xmlns:c="http://schemas.openxmlformats.org/drawingml/2006/chart" r:id="R6f275eaf8e2545a7"/>
+            <c:chart xmlns:r="http://schemas.openxmlformats.org/officeDocument/2006/relationships" xmlns:c="http://schemas.openxmlformats.org/drawingml/2006/chart" r:id="R501bdfdc79714eb2"/>
           </a:graphicData>
         </a:graphic>
       </p:graphicFrame>
       <p:sp>
         <p:nvSpPr>
-          <p:cNvPr id="11" name="">
+          <p:cNvPr id="9" name="">
             <a:extLst xmlns:a="http://schemas.openxmlformats.org/drawingml/2006/main">
               <a:ext uri="{FF2B5EF4-FFF2-40B4-BE49-F238E27FC236}">
-                <a16:creationId xmlns:a16="http://schemas.microsoft.com/office/drawing/2014/main" id="{01E32625-0510-46BD-B177-30D1DF0407ED}"/>
+                <a16:creationId xmlns:a16="http://schemas.microsoft.com/office/drawing/2014/main" id="{76727C41-457E-4347-9B05-6981350249B0}"/>
               </a:ext>
             </a:extLst>
           </p:cNvPr>
@@ -2249,8 +2135,8 @@
         </p:nvSpPr>
         <p:spPr>
           <a:xfrm xmlns:a="http://schemas.openxmlformats.org/drawingml/2006/main">
-            <a:off x="4524375" y="2447925"/>
-            <a:ext cx="1524000" cy="266700"/>
+            <a:off x="4619625" y="2362200"/>
+            <a:ext cx="1524000" cy="304800"/>
           </a:xfrm>
           <a:prstGeom xmlns:a="http://schemas.openxmlformats.org/drawingml/2006/main" prst="rect">
             <a:avLst/>
@@ -2290,67 +2176,10 @@
           </a:p>
         </p:txBody>
       </p:sp>
-      <p:sp>
-        <p:nvSpPr>
-          <p:cNvPr id="12" name="">
-            <a:extLst xmlns:a="http://schemas.openxmlformats.org/drawingml/2006/main">
-              <a:ext uri="{FF2B5EF4-FFF2-40B4-BE49-F238E27FC236}">
-                <a16:creationId xmlns:a16="http://schemas.microsoft.com/office/drawing/2014/main" id="{BEB1FB34-5600-4A8C-A17C-9380AC27484C}"/>
-              </a:ext>
-            </a:extLst>
-          </p:cNvPr>
-          <p:cNvSpPr>
-            <a:spLocks xmlns:a="http://schemas.openxmlformats.org/drawingml/2006/main" noGrp="1"/>
-          </p:cNvSpPr>
-          <p:nvPr/>
-        </p:nvSpPr>
-        <p:spPr>
-          <a:xfrm xmlns:a="http://schemas.openxmlformats.org/drawingml/2006/main">
-            <a:off x="619125" y="6296025"/>
-            <a:ext cx="10858500" cy="295275"/>
-          </a:xfrm>
-          <a:prstGeom xmlns:a="http://schemas.openxmlformats.org/drawingml/2006/main" prst="rect">
-            <a:avLst/>
-          </a:prstGeom>
-          <a:noFill xmlns:a="http://schemas.openxmlformats.org/drawingml/2006/main"/>
-          <a:ln xmlns:a="http://schemas.openxmlformats.org/drawingml/2006/main" w="0">
-            <a:noFill/>
-          </a:ln>
-        </p:spPr>
-        <p:txBody>
-          <a:bodyPr xmlns:a="http://schemas.openxmlformats.org/drawingml/2006/main">
-            <a:noAutofit/>
-          </a:bodyPr>
-          <a:lstStyle xmlns:a="http://schemas.openxmlformats.org/drawingml/2006/main"/>
-          <a:p xmlns:a="http://schemas.openxmlformats.org/drawingml/2006/main">
-            <a:pPr>
-              <a:defRPr sz="1425" b="0">
-                <a:solidFill>
-                  <a:srgbClr val="637267"/>
-                </a:solidFill>
-                <a:latin typeface="Helvetica Neue"/>
-                <a:ea typeface="Helvetica Neue"/>
-                <a:cs typeface="Helvetica Neue"/>
-              </a:defRPr>
-            </a:pPr>
-            <a:r>
-              <a:rPr sz="1425" b="0">
-                <a:solidFill>
-                  <a:srgbClr val="637267"/>
-                </a:solidFill>
-                <a:latin typeface="Helvetica Neue"/>
-                <a:ea typeface="Helvetica Neue"/>
-                <a:cs typeface="Helvetica Neue"/>
-              </a:rPr>
-              <a:t>Every dated valuation precedes July 1. Missing outcomes remain unknown.</a:t>
-            </a:r>
-          </a:p>
-        </p:txBody>
-      </p:sp>
     </p:spTree>
     <p:extLst>
       <p:ext uri="{BB962C8B-B14F-4D97-AF65-F5344CB8AC3E}">
-        <p14:creationId xmlns:p14="http://schemas.microsoft.com/office/powerpoint/2010/main" val="777022552"/>
+        <p14:creationId xmlns:p14="http://schemas.microsoft.com/office/powerpoint/2010/main" val="1004040209"/>
       </p:ext>
     </p:extLst>
   </p:cSld>
@@ -2378,10 +2207,10 @@
       </p:grpSpPr>
       <p:sp>
         <p:nvSpPr>
-          <p:cNvPr id="12" name="">
+          <p:cNvPr id="10" name="">
             <a:extLst xmlns:a="http://schemas.openxmlformats.org/drawingml/2006/main">
               <a:ext uri="{FF2B5EF4-FFF2-40B4-BE49-F238E27FC236}">
-                <a16:creationId xmlns:a16="http://schemas.microsoft.com/office/drawing/2014/main" id="{D6699856-500D-4103-BE3D-8AE65A3D9853}"/>
+                <a16:creationId xmlns:a16="http://schemas.microsoft.com/office/drawing/2014/main" id="{2F3462EF-0579-4482-950C-8653B0541C9D}"/>
               </a:ext>
             </a:extLst>
           </p:cNvPr>
@@ -2392,8 +2221,122 @@
         </p:nvSpPr>
         <p:spPr>
           <a:xfrm xmlns:a="http://schemas.openxmlformats.org/drawingml/2006/main">
-            <a:off x="609600" y="352425"/>
-            <a:ext cx="9525000" cy="285750"/>
+            <a:off x="571500" y="838200"/>
+            <a:ext cx="11049000" cy="876300"/>
+          </a:xfrm>
+          <a:prstGeom xmlns:a="http://schemas.openxmlformats.org/drawingml/2006/main" prst="rect">
+            <a:avLst/>
+          </a:prstGeom>
+          <a:noFill xmlns:a="http://schemas.openxmlformats.org/drawingml/2006/main"/>
+          <a:ln xmlns:a="http://schemas.openxmlformats.org/drawingml/2006/main" w="0">
+            <a:noFill/>
+          </a:ln>
+        </p:spPr>
+        <p:txBody>
+          <a:bodyPr xmlns:a="http://schemas.openxmlformats.org/drawingml/2006/main">
+            <a:noAutofit/>
+          </a:bodyPr>
+          <a:lstStyle xmlns:a="http://schemas.openxmlformats.org/drawingml/2006/main"/>
+          <a:p xmlns:a="http://schemas.openxmlformats.org/drawingml/2006/main">
+            <a:pPr>
+              <a:defRPr sz="4650" b="0">
+                <a:solidFill>
+                  <a:srgbClr val="F7F5F0"/>
+                </a:solidFill>
+                <a:latin typeface="Georgia"/>
+                <a:ea typeface="Georgia"/>
+                <a:cs typeface="Georgia"/>
+              </a:defRPr>
+            </a:pPr>
+            <a:r>
+              <a:rPr sz="4650" b="0">
+                <a:solidFill>
+                  <a:srgbClr val="F7F5F0"/>
+                </a:solidFill>
+                <a:latin typeface="Georgia"/>
+                <a:ea typeface="Georgia"/>
+                <a:cs typeface="Georgia"/>
+              </a:rPr>
+              <a:t>Sensitivity to input changes</a:t>
+            </a:r>
+          </a:p>
+        </p:txBody>
+      </p:sp>
+      <p:sp>
+        <p:nvSpPr>
+          <p:cNvPr id="2" name="">
+            <a:extLst xmlns:a="http://schemas.openxmlformats.org/drawingml/2006/main">
+              <a:ext uri="{FF2B5EF4-FFF2-40B4-BE49-F238E27FC236}">
+                <a16:creationId xmlns:a16="http://schemas.microsoft.com/office/drawing/2014/main" id="{7B30A09A-A44D-4DDA-BE44-70990EB71F7D}"/>
+              </a:ext>
+            </a:extLst>
+          </p:cNvPr>
+          <p:cNvSpPr>
+            <a:spLocks xmlns:a="http://schemas.openxmlformats.org/drawingml/2006/main" noGrp="1"/>
+          </p:cNvSpPr>
+          <p:nvPr/>
+        </p:nvSpPr>
+        <p:spPr>
+          <a:xfrm xmlns:a="http://schemas.openxmlformats.org/drawingml/2006/main">
+            <a:off x="619125" y="1809750"/>
+            <a:ext cx="10668000" cy="400050"/>
+          </a:xfrm>
+          <a:prstGeom xmlns:a="http://schemas.openxmlformats.org/drawingml/2006/main" prst="rect">
+            <a:avLst/>
+          </a:prstGeom>
+          <a:noFill xmlns:a="http://schemas.openxmlformats.org/drawingml/2006/main"/>
+          <a:ln xmlns:a="http://schemas.openxmlformats.org/drawingml/2006/main" w="0">
+            <a:noFill/>
+          </a:ln>
+        </p:spPr>
+        <p:txBody>
+          <a:bodyPr xmlns:a="http://schemas.openxmlformats.org/drawingml/2006/main">
+            <a:noAutofit/>
+          </a:bodyPr>
+          <a:lstStyle xmlns:a="http://schemas.openxmlformats.org/drawingml/2006/main"/>
+          <a:p xmlns:a="http://schemas.openxmlformats.org/drawingml/2006/main">
+            <a:pPr>
+              <a:defRPr sz="1875" b="0">
+                <a:solidFill>
+                  <a:srgbClr val="C0D2C4"/>
+                </a:solidFill>
+                <a:latin typeface="Helvetica Neue"/>
+                <a:ea typeface="Helvetica Neue"/>
+                <a:cs typeface="Helvetica Neue"/>
+              </a:defRPr>
+            </a:pPr>
+            <a:r>
+              <a:rPr sz="1875" b="0">
+                <a:solidFill>
+                  <a:srgbClr val="C0D2C4"/>
+                </a:solidFill>
+                <a:latin typeface="Helvetica Neue"/>
+                <a:ea typeface="Helvetica Neue"/>
+                <a:cs typeface="Helvetica Neue"/>
+              </a:rPr>
+              <a:t>1% training-SD noise on age, height and valuations</a:t>
+            </a:r>
+          </a:p>
+        </p:txBody>
+      </p:sp>
+      <p:sp>
+        <p:nvSpPr>
+          <p:cNvPr id="3" name="">
+            <a:extLst xmlns:a="http://schemas.openxmlformats.org/drawingml/2006/main">
+              <a:ext uri="{FF2B5EF4-FFF2-40B4-BE49-F238E27FC236}">
+                <a16:creationId xmlns:a16="http://schemas.microsoft.com/office/drawing/2014/main" id="{727C7110-F61F-441B-AF2B-3FB097E9FBCE}"/>
+              </a:ext>
+            </a:extLst>
+          </p:cNvPr>
+          <p:cNvSpPr>
+            <a:spLocks xmlns:a="http://schemas.openxmlformats.org/drawingml/2006/main" noGrp="1"/>
+          </p:cNvSpPr>
+          <p:nvPr/>
+        </p:nvSpPr>
+        <p:spPr>
+          <a:xfrm xmlns:a="http://schemas.openxmlformats.org/drawingml/2006/main">
+            <a:off x="628650" y="2828925"/>
+            <a:ext cx="3524250" cy="285750"/>
           </a:xfrm>
           <a:prstGeom xmlns:a="http://schemas.openxmlformats.org/drawingml/2006/main" prst="rect">
             <a:avLst/>
@@ -2412,7 +2355,7 @@
             <a:pPr>
               <a:defRPr sz="1200" b="1">
                 <a:solidFill>
-                  <a:srgbClr val="B3C6B8"/>
+                  <a:srgbClr val="C0D2C4"/>
                 </a:solidFill>
                 <a:latin typeface="Helvetica Neue"/>
                 <a:ea typeface="Helvetica Neue"/>
@@ -2422,23 +2365,23 @@
             <a:r>
               <a:rPr sz="1200" b="1">
                 <a:solidFill>
-                  <a:srgbClr val="B3C6B8"/>
+                  <a:srgbClr val="C0D2C4"/>
                 </a:solidFill>
                 <a:latin typeface="Helvetica Neue"/>
                 <a:ea typeface="Helvetica Neue"/>
                 <a:cs typeface="Helvetica Neue"/>
               </a:rPr>
-              <a:t>FOOTBALL RECRUITMENT</a:t>
+              <a:t>LOGISTIC REGRESSION</a:t>
             </a:r>
           </a:p>
         </p:txBody>
       </p:sp>
       <p:sp>
         <p:nvSpPr>
-          <p:cNvPr id="2" name="">
+          <p:cNvPr id="4" name="">
             <a:extLst xmlns:a="http://schemas.openxmlformats.org/drawingml/2006/main">
               <a:ext uri="{FF2B5EF4-FFF2-40B4-BE49-F238E27FC236}">
-                <a16:creationId xmlns:a16="http://schemas.microsoft.com/office/drawing/2014/main" id="{32984A56-4E55-46FC-8D28-FA98CC30BB28}"/>
+                <a16:creationId xmlns:a16="http://schemas.microsoft.com/office/drawing/2014/main" id="{41E3D5B8-5B73-4EB2-A4E6-0947A148A3BB}"/>
               </a:ext>
             </a:extLst>
           </p:cNvPr>
@@ -2449,8 +2392,8 @@
         </p:nvSpPr>
         <p:spPr>
           <a:xfrm xmlns:a="http://schemas.openxmlformats.org/drawingml/2006/main">
-            <a:off x="11049000" y="314325"/>
-            <a:ext cx="666750" cy="400050"/>
+            <a:off x="533400" y="3162300"/>
+            <a:ext cx="2952750" cy="1209675"/>
           </a:xfrm>
           <a:prstGeom xmlns:a="http://schemas.openxmlformats.org/drawingml/2006/main" prst="rect">
             <a:avLst/>
@@ -2467,7 +2410,7 @@
           <a:lstStyle xmlns:a="http://schemas.openxmlformats.org/drawingml/2006/main"/>
           <a:p xmlns:a="http://schemas.openxmlformats.org/drawingml/2006/main">
             <a:pPr>
-              <a:defRPr sz="2100" b="0">
+              <a:defRPr sz="7875" b="0">
                 <a:solidFill>
                   <a:srgbClr val="F7F5F0"/>
                 </a:solidFill>
@@ -2477,7 +2420,7 @@
               </a:defRPr>
             </a:pPr>
             <a:r>
-              <a:rPr sz="2100" b="0">
+              <a:rPr sz="7875" b="0">
                 <a:solidFill>
                   <a:srgbClr val="F7F5F0"/>
                 </a:solidFill>
@@ -2485,17 +2428,17 @@
                 <a:ea typeface="Georgia"/>
                 <a:cs typeface="Georgia"/>
               </a:rPr>
-              <a:t>02</a:t>
+              <a:t>0.10</a:t>
             </a:r>
           </a:p>
         </p:txBody>
       </p:sp>
       <p:sp>
         <p:nvSpPr>
-          <p:cNvPr id="3" name="">
+          <p:cNvPr id="5" name="">
             <a:extLst xmlns:a="http://schemas.openxmlformats.org/drawingml/2006/main">
               <a:ext uri="{FF2B5EF4-FFF2-40B4-BE49-F238E27FC236}">
-                <a16:creationId xmlns:a16="http://schemas.microsoft.com/office/drawing/2014/main" id="{2B78E093-219A-45C3-B27C-9350D07A59A0}"/>
+                <a16:creationId xmlns:a16="http://schemas.microsoft.com/office/drawing/2014/main" id="{D5D16754-72F4-4AC2-8227-68972695F1B3}"/>
               </a:ext>
             </a:extLst>
           </p:cNvPr>
@@ -2506,8 +2449,8 @@
         </p:nvSpPr>
         <p:spPr>
           <a:xfrm xmlns:a="http://schemas.openxmlformats.org/drawingml/2006/main">
-            <a:off x="571500" y="1066800"/>
-            <a:ext cx="4514850" cy="1581150"/>
+            <a:off x="3048000" y="3752850"/>
+            <a:ext cx="714375" cy="457200"/>
           </a:xfrm>
           <a:prstGeom xmlns:a="http://schemas.openxmlformats.org/drawingml/2006/main" prst="rect">
             <a:avLst/>
@@ -2524,9 +2467,9 @@
           <a:lstStyle xmlns:a="http://schemas.openxmlformats.org/drawingml/2006/main"/>
           <a:p xmlns:a="http://schemas.openxmlformats.org/drawingml/2006/main">
             <a:pPr>
-              <a:defRPr sz="4575" b="0">
-                <a:solidFill>
-                  <a:srgbClr val="F7F5F0"/>
+              <a:defRPr sz="2325" b="0">
+                <a:solidFill>
+                  <a:srgbClr val="C0D2C4"/>
                 </a:solidFill>
                 <a:latin typeface="Georgia"/>
                 <a:ea typeface="Georgia"/>
@@ -2534,48 +2477,25 @@
               </a:defRPr>
             </a:pPr>
             <a:r>
-              <a:rPr sz="4575" b="0">
-                <a:solidFill>
-                  <a:srgbClr val="F7F5F0"/>
+              <a:rPr sz="2325" b="0">
+                <a:solidFill>
+                  <a:srgbClr val="C0D2C4"/>
                 </a:solidFill>
                 <a:latin typeface="Georgia"/>
                 <a:ea typeface="Georgia"/>
                 <a:cs typeface="Georgia"/>
               </a:rPr>
-              <a:t>Small changes,</a:t>
-            </a:r>
-          </a:p>
-          <a:p xmlns:a="http://schemas.openxmlformats.org/drawingml/2006/main">
-            <a:pPr>
-              <a:defRPr sz="4575" b="0">
-                <a:solidFill>
-                  <a:srgbClr val="F7F5F0"/>
-                </a:solidFill>
-                <a:latin typeface="Georgia"/>
-                <a:ea typeface="Georgia"/>
-                <a:cs typeface="Georgia"/>
-              </a:defRPr>
-            </a:pPr>
-            <a:r>
-              <a:rPr sz="4575" b="0">
-                <a:solidFill>
-                  <a:srgbClr val="F7F5F0"/>
-                </a:solidFill>
-                <a:latin typeface="Georgia"/>
-                <a:ea typeface="Georgia"/>
-                <a:cs typeface="Georgia"/>
-              </a:rPr>
-              <a:t>stable scores</a:t>
+              <a:t>pp</a:t>
             </a:r>
           </a:p>
         </p:txBody>
       </p:sp>
       <p:sp>
         <p:nvSpPr>
-          <p:cNvPr id="4" name="">
+          <p:cNvPr id="6" name="">
             <a:extLst xmlns:a="http://schemas.openxmlformats.org/drawingml/2006/main">
               <a:ext uri="{FF2B5EF4-FFF2-40B4-BE49-F238E27FC236}">
-                <a16:creationId xmlns:a16="http://schemas.microsoft.com/office/drawing/2014/main" id="{2259057E-9D0F-430E-84BE-4D7EE66B5A94}"/>
+                <a16:creationId xmlns:a16="http://schemas.microsoft.com/office/drawing/2014/main" id="{1F28F811-2F13-4911-9784-B13E6B0936C1}"/>
               </a:ext>
             </a:extLst>
           </p:cNvPr>
@@ -2586,8 +2506,8 @@
         </p:nvSpPr>
         <p:spPr>
           <a:xfrm xmlns:a="http://schemas.openxmlformats.org/drawingml/2006/main">
-            <a:off x="619125" y="2905125"/>
-            <a:ext cx="4143375" cy="695325"/>
+            <a:off x="638175" y="4486275"/>
+            <a:ext cx="3476625" cy="666750"/>
           </a:xfrm>
           <a:prstGeom xmlns:a="http://schemas.openxmlformats.org/drawingml/2006/main" prst="rect">
             <a:avLst/>
@@ -2604,7 +2524,7 @@
           <a:lstStyle xmlns:a="http://schemas.openxmlformats.org/drawingml/2006/main"/>
           <a:p xmlns:a="http://schemas.openxmlformats.org/drawingml/2006/main">
             <a:pPr>
-              <a:defRPr sz="1950" b="0">
+              <a:defRPr sz="1800" b="0">
                 <a:solidFill>
                   <a:srgbClr val="C0D2C4"/>
                 </a:solidFill>
@@ -2614,7 +2534,7 @@
               </a:defRPr>
             </a:pPr>
             <a:r>
-              <a:rPr sz="1950" b="0">
+              <a:rPr sz="1800" b="0">
                 <a:solidFill>
                   <a:srgbClr val="C0D2C4"/>
                 </a:solidFill>
@@ -2622,40 +2542,17 @@
                 <a:ea typeface="Helvetica Neue"/>
                 <a:cs typeface="Helvetica Neue"/>
               </a:rPr>
-              <a:t>Logistic regression under</a:t>
-            </a:r>
-          </a:p>
-          <a:p xmlns:a="http://schemas.openxmlformats.org/drawingml/2006/main">
-            <a:pPr>
-              <a:defRPr sz="1950" b="0">
-                <a:solidFill>
-                  <a:srgbClr val="C0D2C4"/>
-                </a:solidFill>
-                <a:latin typeface="Helvetica Neue"/>
-                <a:ea typeface="Helvetica Neue"/>
-                <a:cs typeface="Helvetica Neue"/>
-              </a:defRPr>
-            </a:pPr>
-            <a:r>
-              <a:rPr sz="1950" b="0">
-                <a:solidFill>
-                  <a:srgbClr val="C0D2C4"/>
-                </a:solidFill>
-                <a:latin typeface="Helvetica Neue"/>
-                <a:ea typeface="Helvetica Neue"/>
-                <a:cs typeface="Helvetica Neue"/>
-              </a:rPr>
-              <a:t>1% measurement noise</a:t>
+              <a:t>Mean absolute score change</a:t>
             </a:r>
           </a:p>
         </p:txBody>
       </p:sp>
       <p:sp>
         <p:nvSpPr>
-          <p:cNvPr id="5" name="">
+          <p:cNvPr id="7" name="">
             <a:extLst xmlns:a="http://schemas.openxmlformats.org/drawingml/2006/main">
               <a:ext uri="{FF2B5EF4-FFF2-40B4-BE49-F238E27FC236}">
-                <a16:creationId xmlns:a16="http://schemas.microsoft.com/office/drawing/2014/main" id="{3524E159-4A06-45DA-A7A8-B6300CD1F860}"/>
+                <a16:creationId xmlns:a16="http://schemas.microsoft.com/office/drawing/2014/main" id="{EED5C1DB-F6FE-4631-BBF9-57E88662B170}"/>
               </a:ext>
             </a:extLst>
           </p:cNvPr>
@@ -2666,8 +2563,8 @@
         </p:nvSpPr>
         <p:spPr>
           <a:xfrm xmlns:a="http://schemas.openxmlformats.org/drawingml/2006/main">
-            <a:off x="561975" y="3829050"/>
-            <a:ext cx="2952750" cy="1133475"/>
+            <a:off x="5476875" y="2400300"/>
+            <a:ext cx="6000750" cy="323850"/>
           </a:xfrm>
           <a:prstGeom xmlns:a="http://schemas.openxmlformats.org/drawingml/2006/main" prst="rect">
             <a:avLst/>
@@ -2684,123 +2581,9 @@
           <a:lstStyle xmlns:a="http://schemas.openxmlformats.org/drawingml/2006/main"/>
           <a:p xmlns:a="http://schemas.openxmlformats.org/drawingml/2006/main">
             <a:pPr>
-              <a:defRPr sz="7200" b="0">
+              <a:defRPr sz="1575" b="0">
                 <a:solidFill>
                   <a:srgbClr val="F7F5F0"/>
-                </a:solidFill>
-                <a:latin typeface="Georgia"/>
-                <a:ea typeface="Georgia"/>
-                <a:cs typeface="Georgia"/>
-              </a:defRPr>
-            </a:pPr>
-            <a:r>
-              <a:rPr sz="7200" b="0">
-                <a:solidFill>
-                  <a:srgbClr val="F7F5F0"/>
-                </a:solidFill>
-                <a:latin typeface="Georgia"/>
-                <a:ea typeface="Georgia"/>
-                <a:cs typeface="Georgia"/>
-              </a:rPr>
-              <a:t>0.10</a:t>
-            </a:r>
-          </a:p>
-        </p:txBody>
-      </p:sp>
-      <p:sp>
-        <p:nvSpPr>
-          <p:cNvPr id="6" name="">
-            <a:extLst xmlns:a="http://schemas.openxmlformats.org/drawingml/2006/main">
-              <a:ext uri="{FF2B5EF4-FFF2-40B4-BE49-F238E27FC236}">
-                <a16:creationId xmlns:a16="http://schemas.microsoft.com/office/drawing/2014/main" id="{9EEF994A-572D-4DCD-BD1D-827FD229DDF1}"/>
-              </a:ext>
-            </a:extLst>
-          </p:cNvPr>
-          <p:cNvSpPr>
-            <a:spLocks xmlns:a="http://schemas.openxmlformats.org/drawingml/2006/main" noGrp="1"/>
-          </p:cNvSpPr>
-          <p:nvPr/>
-        </p:nvSpPr>
-        <p:spPr>
-          <a:xfrm xmlns:a="http://schemas.openxmlformats.org/drawingml/2006/main">
-            <a:off x="3143250" y="4305300"/>
-            <a:ext cx="904875" cy="476250"/>
-          </a:xfrm>
-          <a:prstGeom xmlns:a="http://schemas.openxmlformats.org/drawingml/2006/main" prst="rect">
-            <a:avLst/>
-          </a:prstGeom>
-          <a:noFill xmlns:a="http://schemas.openxmlformats.org/drawingml/2006/main"/>
-          <a:ln xmlns:a="http://schemas.openxmlformats.org/drawingml/2006/main" w="0">
-            <a:noFill/>
-          </a:ln>
-        </p:spPr>
-        <p:txBody>
-          <a:bodyPr xmlns:a="http://schemas.openxmlformats.org/drawingml/2006/main">
-            <a:noAutofit/>
-          </a:bodyPr>
-          <a:lstStyle xmlns:a="http://schemas.openxmlformats.org/drawingml/2006/main"/>
-          <a:p xmlns:a="http://schemas.openxmlformats.org/drawingml/2006/main">
-            <a:pPr>
-              <a:defRPr sz="2625" b="0">
-                <a:solidFill>
-                  <a:srgbClr val="C0D2C4"/>
-                </a:solidFill>
-                <a:latin typeface="Georgia"/>
-                <a:ea typeface="Georgia"/>
-                <a:cs typeface="Georgia"/>
-              </a:defRPr>
-            </a:pPr>
-            <a:r>
-              <a:rPr sz="2625" b="0">
-                <a:solidFill>
-                  <a:srgbClr val="C0D2C4"/>
-                </a:solidFill>
-                <a:latin typeface="Georgia"/>
-                <a:ea typeface="Georgia"/>
-                <a:cs typeface="Georgia"/>
-              </a:rPr>
-              <a:t>pp</a:t>
-            </a:r>
-          </a:p>
-        </p:txBody>
-      </p:sp>
-      <p:sp>
-        <p:nvSpPr>
-          <p:cNvPr id="7" name="">
-            <a:extLst xmlns:a="http://schemas.openxmlformats.org/drawingml/2006/main">
-              <a:ext uri="{FF2B5EF4-FFF2-40B4-BE49-F238E27FC236}">
-                <a16:creationId xmlns:a16="http://schemas.microsoft.com/office/drawing/2014/main" id="{D6E6F951-A4FD-4640-A538-EAEDC5D6E223}"/>
-              </a:ext>
-            </a:extLst>
-          </p:cNvPr>
-          <p:cNvSpPr>
-            <a:spLocks xmlns:a="http://schemas.openxmlformats.org/drawingml/2006/main" noGrp="1"/>
-          </p:cNvSpPr>
-          <p:nvPr/>
-        </p:nvSpPr>
-        <p:spPr>
-          <a:xfrm xmlns:a="http://schemas.openxmlformats.org/drawingml/2006/main">
-            <a:off x="619125" y="5114925"/>
-            <a:ext cx="4114800" cy="361950"/>
-          </a:xfrm>
-          <a:prstGeom xmlns:a="http://schemas.openxmlformats.org/drawingml/2006/main" prst="rect">
-            <a:avLst/>
-          </a:prstGeom>
-          <a:noFill xmlns:a="http://schemas.openxmlformats.org/drawingml/2006/main"/>
-          <a:ln xmlns:a="http://schemas.openxmlformats.org/drawingml/2006/main" w="0">
-            <a:noFill/>
-          </a:ln>
-        </p:spPr>
-        <p:txBody>
-          <a:bodyPr xmlns:a="http://schemas.openxmlformats.org/drawingml/2006/main">
-            <a:noAutofit/>
-          </a:bodyPr>
-          <a:lstStyle xmlns:a="http://schemas.openxmlformats.org/drawingml/2006/main"/>
-          <a:p xmlns:a="http://schemas.openxmlformats.org/drawingml/2006/main">
-            <a:pPr>
-              <a:defRPr sz="1650" b="0">
-                <a:solidFill>
-                  <a:srgbClr val="C0D2C4"/>
                 </a:solidFill>
                 <a:latin typeface="Helvetica Neue"/>
                 <a:ea typeface="Helvetica Neue"/>
@@ -2808,113 +2591,56 @@
               </a:defRPr>
             </a:pPr>
             <a:r>
-              <a:rPr sz="1650" b="0">
-                <a:solidFill>
-                  <a:srgbClr val="C0D2C4"/>
+              <a:rPr sz="1575" b="0">
+                <a:solidFill>
+                  <a:srgbClr val="F7F5F0"/>
                 </a:solidFill>
                 <a:latin typeface="Helvetica Neue"/>
                 <a:ea typeface="Helvetica Neue"/>
                 <a:cs typeface="Helvetica Neue"/>
               </a:rPr>
-              <a:t>Mean absolute score change</a:t>
-            </a:r>
-          </a:p>
-        </p:txBody>
-      </p:sp>
-      <p:sp>
-        <p:nvSpPr>
-          <p:cNvPr id="8" name="">
-            <a:extLst xmlns:a="http://schemas.openxmlformats.org/drawingml/2006/main">
-              <a:ext uri="{FF2B5EF4-FFF2-40B4-BE49-F238E27FC236}">
-                <a16:creationId xmlns:a16="http://schemas.microsoft.com/office/drawing/2014/main" id="{1E4FC2E4-B53A-47FE-89AB-7A21B67E4241}"/>
-              </a:ext>
-            </a:extLst>
-          </p:cNvPr>
-          <p:cNvSpPr>
-            <a:spLocks xmlns:a="http://schemas.openxmlformats.org/drawingml/2006/main" noGrp="1"/>
-          </p:cNvSpPr>
-          <p:nvPr/>
-        </p:nvSpPr>
-        <p:spPr>
-          <a:xfrm xmlns:a="http://schemas.openxmlformats.org/drawingml/2006/main">
-            <a:off x="5372100" y="1504950"/>
-            <a:ext cx="6124575" cy="342900"/>
-          </a:xfrm>
-          <a:prstGeom xmlns:a="http://schemas.openxmlformats.org/drawingml/2006/main" prst="rect">
-            <a:avLst/>
-          </a:prstGeom>
-          <a:noFill xmlns:a="http://schemas.openxmlformats.org/drawingml/2006/main"/>
-          <a:ln xmlns:a="http://schemas.openxmlformats.org/drawingml/2006/main" w="0">
-            <a:noFill/>
-          </a:ln>
-        </p:spPr>
-        <p:txBody>
-          <a:bodyPr xmlns:a="http://schemas.openxmlformats.org/drawingml/2006/main">
-            <a:noAutofit/>
-          </a:bodyPr>
-          <a:lstStyle xmlns:a="http://schemas.openxmlformats.org/drawingml/2006/main"/>
-          <a:p xmlns:a="http://schemas.openxmlformats.org/drawingml/2006/main">
-            <a:pPr>
-              <a:defRPr sz="1725" b="0">
-                <a:solidFill>
-                  <a:srgbClr val="F7F5F0"/>
-                </a:solidFill>
-                <a:latin typeface="Helvetica Neue"/>
-                <a:ea typeface="Helvetica Neue"/>
-                <a:cs typeface="Helvetica Neue"/>
-              </a:defRPr>
-            </a:pPr>
-            <a:r>
-              <a:rPr sz="1725" b="0">
-                <a:solidFill>
-                  <a:srgbClr val="F7F5F0"/>
-                </a:solidFill>
-                <a:latin typeface="Helvetica Neue"/>
-                <a:ea typeface="Helvetica Neue"/>
-                <a:cs typeface="Helvetica Neue"/>
-              </a:rPr>
-              <a:t>Mean score change, percentage points</a:t>
+              <a:t>Mean score change (pp)</a:t>
             </a:r>
           </a:p>
         </p:txBody>
       </p:sp>
       <p:graphicFrame>
         <p:nvGraphicFramePr>
-          <p:cNvPr id="20" name="Chart"/>
+          <p:cNvPr id="17" name="Chart"/>
           <p:cNvGraphicFramePr/>
           <p:nvPr/>
         </p:nvGraphicFramePr>
         <p:xfrm>
-          <a:off xmlns:a="http://schemas.openxmlformats.org/drawingml/2006/main" x="4886325" y="2057400"/>
-          <a:ext xmlns:a="http://schemas.openxmlformats.org/drawingml/2006/main" cx="6715125" cy="2209800"/>
+          <a:off xmlns:a="http://schemas.openxmlformats.org/drawingml/2006/main" x="4924425" y="2809875"/>
+          <a:ext xmlns:a="http://schemas.openxmlformats.org/drawingml/2006/main" cx="6581775" cy="2190750"/>
         </p:xfrm>
         <a:graphic xmlns:a="http://schemas.openxmlformats.org/drawingml/2006/main">
           <a:graphicData uri="http://schemas.openxmlformats.org/drawingml/2006/chart">
-            <c:chart xmlns:r="http://schemas.openxmlformats.org/officeDocument/2006/relationships" xmlns:c="http://schemas.openxmlformats.org/drawingml/2006/chart" r:id="R057319638bbd4f0e"/>
+            <c:chart xmlns:r="http://schemas.openxmlformats.org/officeDocument/2006/relationships" xmlns:c="http://schemas.openxmlformats.org/drawingml/2006/chart" r:id="R699fc9974ed64509"/>
           </a:graphicData>
         </a:graphic>
       </p:graphicFrame>
       <p:graphicFrame>
         <p:nvGraphicFramePr>
-          <p:cNvPr id="21" name=""/>
+          <p:cNvPr id="18" name=""/>
           <p:cNvGraphicFramePr/>
           <p:nvPr/>
         </p:nvGraphicFramePr>
         <p:xfrm>
-          <a:off xmlns:a="http://schemas.openxmlformats.org/drawingml/2006/main" x="5295900" y="4848225"/>
-          <a:ext xmlns:a="http://schemas.openxmlformats.org/drawingml/2006/main" cx="6286500" cy="838200"/>
+          <a:off xmlns:a="http://schemas.openxmlformats.org/drawingml/2006/main" x="5381625" y="5381625"/>
+          <a:ext xmlns:a="http://schemas.openxmlformats.org/drawingml/2006/main" cx="6124575" cy="781050"/>
         </p:xfrm>
         <a:graphic xmlns:a="http://schemas.openxmlformats.org/drawingml/2006/main">
           <a:graphicData uri="http://schemas.openxmlformats.org/drawingml/2006/table">
             <a:tbl>
               <a:tblPr/>
               <a:tblGrid>
-                <a:gridCol w="2343150"/>
-                <a:gridCol w="1304925"/>
-                <a:gridCol w="1304925"/>
-                <a:gridCol w="1333500"/>
+                <a:gridCol w="2181225"/>
+                <a:gridCol w="1314450"/>
+                <a:gridCol w="1314450"/>
+                <a:gridCol w="1314450"/>
               </a:tblGrid>
-              <a:tr h="419100">
+              <a:tr h="390525">
                 <a:tc>
                   <a:txBody>
                     <a:bodyPr/>
@@ -3092,7 +2818,7 @@
                   </a:tcPr>
                 </a:tc>
               </a:tr>
-              <a:tr h="419100">
+              <a:tr h="390525">
                 <a:tc>
                   <a:txBody>
                     <a:bodyPr/>
@@ -3274,67 +3000,10 @@
           </a:graphicData>
         </a:graphic>
       </p:graphicFrame>
-      <p:sp>
-        <p:nvSpPr>
-          <p:cNvPr id="11" name="">
-            <a:extLst xmlns:a="http://schemas.openxmlformats.org/drawingml/2006/main">
-              <a:ext uri="{FF2B5EF4-FFF2-40B4-BE49-F238E27FC236}">
-                <a16:creationId xmlns:a16="http://schemas.microsoft.com/office/drawing/2014/main" id="{E98BD841-E863-45E0-A4A4-911A633005DD}"/>
-              </a:ext>
-            </a:extLst>
-          </p:cNvPr>
-          <p:cNvSpPr>
-            <a:spLocks xmlns:a="http://schemas.openxmlformats.org/drawingml/2006/main" noGrp="1"/>
-          </p:cNvSpPr>
-          <p:nvPr/>
-        </p:nvSpPr>
-        <p:spPr>
-          <a:xfrm xmlns:a="http://schemas.openxmlformats.org/drawingml/2006/main">
-            <a:off x="619125" y="6210300"/>
-            <a:ext cx="10953750" cy="466725"/>
-          </a:xfrm>
-          <a:prstGeom xmlns:a="http://schemas.openxmlformats.org/drawingml/2006/main" prst="rect">
-            <a:avLst/>
-          </a:prstGeom>
-          <a:noFill xmlns:a="http://schemas.openxmlformats.org/drawingml/2006/main"/>
-          <a:ln xmlns:a="http://schemas.openxmlformats.org/drawingml/2006/main" w="0">
-            <a:noFill/>
-          </a:ln>
-        </p:spPr>
-        <p:txBody>
-          <a:bodyPr xmlns:a="http://schemas.openxmlformats.org/drawingml/2006/main">
-            <a:noAutofit/>
-          </a:bodyPr>
-          <a:lstStyle xmlns:a="http://schemas.openxmlformats.org/drawingml/2006/main"/>
-          <a:p xmlns:a="http://schemas.openxmlformats.org/drawingml/2006/main">
-            <a:pPr>
-              <a:defRPr sz="1425" b="0">
-                <a:solidFill>
-                  <a:srgbClr val="B3C6B8"/>
-                </a:solidFill>
-                <a:latin typeface="Helvetica Neue"/>
-                <a:ea typeface="Helvetica Neue"/>
-                <a:cs typeface="Helvetica Neue"/>
-              </a:defRPr>
-            </a:pPr>
-            <a:r>
-              <a:rPr sz="1425" b="0">
-                <a:solidFill>
-                  <a:srgbClr val="B3C6B8"/>
-                </a:solidFill>
-                <a:latin typeface="Helvetica Neue"/>
-                <a:ea typeface="Helvetica Neue"/>
-                <a:cs typeface="Helvetica Neue"/>
-              </a:rPr>
-              <a:t>Noise uses 1% of training SD on age, height and valuations. PSI measures score distribution shift.</a:t>
-            </a:r>
-          </a:p>
-        </p:txBody>
-      </p:sp>
     </p:spTree>
     <p:extLst>
       <p:ext uri="{BB962C8B-B14F-4D97-AF65-F5344CB8AC3E}">
-        <p14:creationId xmlns:p14="http://schemas.microsoft.com/office/powerpoint/2010/main" val="193747441"/>
+        <p14:creationId xmlns:p14="http://schemas.microsoft.com/office/powerpoint/2010/main" val="242305215"/>
       </p:ext>
     </p:extLst>
   </p:cSld>

</xml_diff>